<commit_message>
Enrich PPT with speaker notes, fill repo URL
</commit_message>
<xml_diff>
--- a/presentation.pptx
+++ b/presentation.pptx
@@ -473,8 +473,7 @@
           <a:lstStyle xmlns:a="http://schemas.openxmlformats.org/drawingml/2006/main"/>
           <a:p xmlns:a="http://schemas.openxmlformats.org/drawingml/2006/main">
             <a:r>
-              <a:rPr lang="zh-CN"/>
-              <a:t>先说使用者和问题，不讲课程日名称代替问题。指出真实输入和产品边界。目标 30 秒。</a:t>
+              <a:t>大家好，我们是好难起名组。今天要解决的问题是：为设施维护团队做一个混凝土裂缝的初步筛查器。他们的工作流程是先大量拍照、再人工复核，非常耗时。我们希望模型先筛出疑似裂缝的照片，让维护人员优先复核这些，从而减少无效的复核工作量。需要强调，这个筛查器只用来排序复核优先级，不能替代现场检查、工程师判断或结构安全结论。</a:t>
             </a:r>
           </a:p>
         </p:txBody>
@@ -528,8 +527,7 @@
           <a:lstStyle xmlns:a="http://schemas.openxmlformats.org/drawingml/2006/main"/>
           <a:p xmlns:a="http://schemas.openxmlformats.org/drawingml/2006/main">
             <a:r>
-              <a:rPr lang="zh-CN"/>
-              <a:t>说明基线为何简单、候选只复杂哪一步，以及比较条件如何保持相同。目标 45 秒。</a:t>
+              <a:t>我们的真实数据来自 Kaggle 的 Surface Crack Detection 数据集，Positive 和 Negative 各两万张，用 --check-data 验证通过。先看最简单的多数类基线：把所有图都判为裂缝，准确率只有 0.5，而且误报了 150 张无裂缝图，几乎不可用。候选方法是我们自己实现的小型 CNN，两层卷积加池化再接全连接。我们保持了数据的划分、指标和训练流程都不变，只改了模型本身。</a:t>
             </a:r>
           </a:p>
         </p:txBody>
@@ -583,8 +581,7 @@
           <a:lstStyle xmlns:a="http://schemas.openxmlformats.org/drawingml/2006/main"/>
           <a:p xmlns:a="http://schemas.openxmlformats.org/drawingml/2006/main">
             <a:r>
-              <a:rPr lang="zh-CN"/>
-              <a:t>只选择一条最能回答问题的证据。说出命令、指标含义和一个真实样本。目标 60 秒。</a:t>
+              <a:t>这是最重要的一条证据。在同样 900 训练、300 测试的划分下，CNN 训练 8 个 epoch 后准确率 0.943，漏检 14 张裂缝，误报只有 3 张，而基线误报了 150 张，误报率大幅下降。左边这个案例是一张被漏检的真实裂缝 04283.jpg，模型把它判成了无裂缝，而且它在 2 个 epoch 和 8 个 epoch 时都被漏检。这提醒我们，虽然误报大幅减少，但漏检还没清零，而漏检恰恰是筛查场景最需要警惕的。</a:t>
             </a:r>
           </a:p>
         </p:txBody>
@@ -638,8 +635,7 @@
           <a:lstStyle xmlns:a="http://schemas.openxmlformats.org/drawingml/2006/main"/>
           <a:p xmlns:a="http://schemas.openxmlformats.org/drawingml/2006/main">
             <a:r>
-              <a:rPr lang="zh-CN"/>
-              <a:t>用失败收尾，明确不能声称什么和下一项最小检查。不要说泛泛的“数据不够”。目标 45 秒。</a:t>
+              <a:t>最后是失败、限制与下一步。我们的 CNN 仍然漏检 14 张裂缝，比 2 个 epoch 的 43 张已经大幅改善，但没有清零。必须强调的是，这个模型只能用于安排人工复核的顺序，不能替代现场检查、工程师判断或结构安全结论。而且数据是由高分辨率照片切块生成的，随机拆分存在泄漏风险，数字可能偏乐观。下一步的最小检查是查看错误图像网格，归纳漏检样本的共性，比如亮度、裂缝粗细或对比度，再决定是否做针对性数据增强。谢谢大家。</a:t>
             </a:r>
           </a:p>
         </p:txBody>
@@ -1063,7 +1059,7 @@
                 <a:latin typeface="Microsoft YaHei"/>
                 <a:ea typeface="Microsoft YaHei"/>
               </a:rPr>
-              <a:t>设施维护团队需先从大量混凝土照片中筛出疑似裂缝、再安排人工复核。输入：混凝土表面照片；输出：疑似裂缝/无裂缝；用于决定哪些照片优先复核。</a:t>
+              <a:t>设施维护团队需先从大量混凝土照片中筛出疑似裂缝、再安排人工复核。输入：混凝土表面照片；输出：疑似裂缝 / 无裂缝；用于决定哪些照片优先复核。模型只排序复核优先级，不替代现场检查与工程判断。</a:t>
             </a:r>
           </a:p>
         </p:txBody>
@@ -1271,8 +1267,8 @@
                 <a:latin typeface="Microsoft YaHei"/>
                 <a:ea typeface="Microsoft YaHei"/>
               </a:rPr>
-              <a:t>Kaggle Surface Crack Detection
-Positive / Negative 各 20000 张
+              <a:t>来源：Kaggle Surface Crack Detection
+Positive / Negative 各 20000 张（227×227 RGB）
 python train.py --check-data 通过</a:t>
             </a:r>
           </a:p>
@@ -1327,8 +1323,9 @@
                 <a:latin typeface="Microsoft YaHei"/>
                 <a:ea typeface="Microsoft YaHei"/>
               </a:rPr>
-              <a:t>多数类：全部判为裂缝
-acc 0.50 ｜ 误报 150</a:t>
+              <a:t>多数类：所有图判为裂缝
+acc 0.50 ｜ recall 1.0
+误报 150 / 300</a:t>
             </a:r>
           </a:p>
         </p:txBody>
@@ -1383,7 +1380,8 @@
                 <a:ea typeface="Microsoft YaHei"/>
               </a:rPr>
               <a:t>SmallCNN（2 卷积 + 2 池化 + 线性）
-acc 0.943 ｜ 漏检 14 ｜ 误报 3</a:t>
+acc 0.943 ｜ recall 0.907
+漏检 14 ｜ 误报 3</a:t>
             </a:r>
           </a:p>
         </p:txBody>
@@ -1418,7 +1416,7 @@
                 <a:latin typeface="Microsoft YaHei"/>
                 <a:ea typeface="Microsoft YaHei"/>
               </a:rPr>
-              <a:t>数据划分：每类最多 600、75/25、seed 2026；指标 accuracy / 漏检 / 误报均未改动。</a:t>
+              <a:t>不变条件：数据划分每类最多 600、75/25、seed 2026；指标与训练流程均未改动。</a:t>
             </a:r>
           </a:p>
         </p:txBody>
@@ -1593,7 +1591,8 @@
               </a:rPr>
               <a:t>CNN 8ep：acc 0.943
 漏检 14 ｜ 误报 3（基线误报 150）
-900 训练 / 300 测试</a:t>
+900 训练 / 300 测试
+train_loss 0.68 → 0.20</a:t>
             </a:r>
           </a:p>
         </p:txBody>
@@ -1648,7 +1647,8 @@
                 <a:ea typeface="Microsoft YaHei"/>
               </a:rPr>
               <a:t>漏检裂缝 data/raw/Positive/04283.jpg
-true=crack，predicted=no_crack</a:t>
+true=crack，predicted=no_crack
+在 2ep 与 8ep 中均被漏检</a:t>
             </a:r>
           </a:p>
         </p:txBody>
@@ -1683,7 +1683,7 @@
                 <a:latin typeface="Microsoft YaHei"/>
                 <a:ea typeface="Microsoft YaHei"/>
               </a:rPr>
-              <a:t>由 python train.py --model cnn --epochs 8 生成；数字见 runs/cnn.json。</a:t>
+              <a:t>由 python train.py --model cnn --epochs 8 生成；数字见 runs/cnn.json，可复现。</a:t>
             </a:r>
           </a:p>
         </p:txBody>
@@ -1795,7 +1795,8 @@
                 <a:ea typeface="Microsoft YaHei"/>
               </a:rPr>
               <a:t>CNN 8ep 仍漏检 14 张裂缝
-（2ep 为 43，明显改善但未清零）</a:t>
+2ep 为 43 → 8ep 为 14，未清零
+漏检是筛查场景最危险的错误</a:t>
             </a:r>
           </a:p>
         </p:txBody>
@@ -1850,7 +1851,8 @@
                 <a:ea typeface="Microsoft YaHei"/>
               </a:rPr>
               <a:t>不能替代现场检查 / 工程师判断 / 安全决策
-切块数据存在泄漏，数字偏乐观</a:t>
+切块数据存在泄漏，数字偏乐观
+仅用于安排复核排序</a:t>
             </a:r>
           </a:p>
         </p:txBody>
@@ -1905,7 +1907,8 @@
                 <a:ea typeface="Microsoft YaHei"/>
               </a:rPr>
               <a:t>查看 runs/cnn-errors.png 归纳漏检共性
-（亮度 / 裂缝粗细 / 对比度），考虑数据增强</a:t>
+（亮度 / 裂缝粗细 / 对比度）
+再考虑针对性数据增强</a:t>
             </a:r>
           </a:p>
         </p:txBody>

</xml_diff>

<commit_message>
Fix PPT content bullets
</commit_message>
<xml_diff>
--- a/presentation.pptx
+++ b/presentation.pptx
@@ -4330,7 +4330,7 @@
           <a:p>
             <a:pPr algn="ctr"/>
             <a:r>
-              <a:rPr sz="4400" b="1" i="0">
+              <a:rPr sz="4400" b="1">
                 <a:solidFill>
                   <a:srgbClr val="FFFFFF"/>
                 </a:solidFill>
@@ -4366,7 +4366,7 @@
           <a:p>
             <a:pPr algn="ctr"/>
             <a:r>
-              <a:rPr sz="2000" b="0" i="0">
+              <a:rPr sz="2000" b="0">
                 <a:solidFill>
                   <a:srgbClr val="CFDDEC"/>
                 </a:solidFill>
@@ -4402,7 +4402,7 @@
           <a:p>
             <a:pPr algn="ctr"/>
             <a:r>
-              <a:rPr sz="1600" b="0" i="0">
+              <a:rPr sz="1600" b="0">
                 <a:solidFill>
                   <a:srgbClr val="E8E8E8"/>
                 </a:solidFill>
@@ -4415,7 +4415,7 @@
           <a:p>
             <a:pPr algn="ctr"/>
             <a:r>
-              <a:rPr sz="1400" b="0" i="0">
+              <a:rPr sz="1400" b="0">
                 <a:solidFill>
                   <a:srgbClr val="AFC2D6"/>
                 </a:solidFill>
@@ -4512,7 +4512,7 @@
           <a:lstStyle/>
           <a:p>
             <a:r>
-              <a:rPr sz="3000" b="1" i="0">
+              <a:rPr sz="3000" b="1">
                 <a:solidFill>
                   <a:srgbClr val="FFFFFF"/>
                 </a:solidFill>
@@ -4596,14 +4596,14 @@
               </a:spcAft>
             </a:pPr>
             <a:r>
-              <a:rPr sz="2000" b="1" i="0">
+              <a:rPr sz="2000" b="1">
                 <a:solidFill>
                   <a:srgbClr val="1F3A5F"/>
                 </a:solidFill>
                 <a:latin typeface="Microsoft YaHei"/>
                 <a:ea typeface="Microsoft YaHei"/>
               </a:rPr>
-              <a:t>•  </a:t>
+              <a:t>•  CNN 8ep 仍漏检 14 张裂缝（2ep 为 43，已大幅改善但未清零）</a:t>
             </a:r>
           </a:p>
           <a:p>
@@ -4613,14 +4613,14 @@
               </a:spcAft>
             </a:pPr>
             <a:r>
-              <a:rPr sz="2000" b="1" i="0">
+              <a:rPr sz="2000" b="1">
                 <a:solidFill>
                   <a:srgbClr val="1F3A5F"/>
                 </a:solidFill>
                 <a:latin typeface="Microsoft YaHei"/>
                 <a:ea typeface="Microsoft YaHei"/>
               </a:rPr>
-              <a:t>•  </a:t>
+              <a:t>•  不能替代现场检查 / 工程师判断 / 结构安全决策</a:t>
             </a:r>
           </a:p>
           <a:p>
@@ -4630,14 +4630,14 @@
               </a:spcAft>
             </a:pPr>
             <a:r>
-              <a:rPr sz="2000" b="0" i="0">
+              <a:rPr sz="2000" b="0">
                 <a:solidFill>
                   <a:srgbClr val="1F3A5F"/>
                 </a:solidFill>
                 <a:latin typeface="Microsoft YaHei"/>
                 <a:ea typeface="Microsoft YaHei"/>
               </a:rPr>
-              <a:t>•  </a:t>
+              <a:t>•  切块数据存在泄漏，数字可能偏乐观</a:t>
             </a:r>
           </a:p>
           <a:p>
@@ -4647,14 +4647,14 @@
               </a:spcAft>
             </a:pPr>
             <a:r>
-              <a:rPr sz="2000" b="0" i="0">
+              <a:rPr sz="2000" b="0">
                 <a:solidFill>
                   <a:srgbClr val="1F3A5F"/>
                 </a:solidFill>
                 <a:latin typeface="Microsoft YaHei"/>
                 <a:ea typeface="Microsoft YaHei"/>
               </a:rPr>
-              <a:t>•  </a:t>
+              <a:t>•  只用于安排人工复核排序</a:t>
             </a:r>
           </a:p>
         </p:txBody>
@@ -4683,7 +4683,7 @@
           <a:p>
             <a:pPr algn="r"/>
             <a:r>
-              <a:rPr sz="1200" b="0" i="0">
+              <a:rPr sz="1200" b="0">
                 <a:solidFill>
                   <a:srgbClr val="4A4A4A"/>
                 </a:solidFill>
@@ -4780,7 +4780,7 @@
           <a:lstStyle/>
           <a:p>
             <a:r>
-              <a:rPr sz="3000" b="1" i="0">
+              <a:rPr sz="3000" b="1">
                 <a:solidFill>
                   <a:srgbClr val="FFFFFF"/>
                 </a:solidFill>
@@ -4864,14 +4864,14 @@
               </a:spcAft>
             </a:pPr>
             <a:r>
-              <a:rPr sz="2000" b="1" i="0">
+              <a:rPr sz="2000" b="1">
                 <a:solidFill>
                   <a:srgbClr val="1F3A5F"/>
                 </a:solidFill>
                 <a:latin typeface="Microsoft YaHei"/>
                 <a:ea typeface="Microsoft YaHei"/>
               </a:rPr>
-              <a:t>•  </a:t>
+              <a:t>•  结论：CNN 显著优于多数类基线，大幅减少人工复核量</a:t>
             </a:r>
           </a:p>
           <a:p>
@@ -4881,14 +4881,14 @@
               </a:spcAft>
             </a:pPr>
             <a:r>
-              <a:rPr sz="2000" b="0" i="0">
+              <a:rPr sz="2000" b="0">
                 <a:solidFill>
                   <a:srgbClr val="1F3A5F"/>
                 </a:solidFill>
                 <a:latin typeface="Microsoft YaHei"/>
                 <a:ea typeface="Microsoft YaHei"/>
               </a:rPr>
-              <a:t>•  </a:t>
+              <a:t>•  下一步：查看漏检图像共性（亮度 / 裂缝粗细 / 对比度）</a:t>
             </a:r>
           </a:p>
           <a:p>
@@ -4898,14 +4898,14 @@
               </a:spcAft>
             </a:pPr>
             <a:r>
-              <a:rPr sz="2000" b="0" i="0">
+              <a:rPr sz="2000" b="0">
                 <a:solidFill>
                   <a:srgbClr val="1F3A5F"/>
                 </a:solidFill>
                 <a:latin typeface="Microsoft YaHei"/>
                 <a:ea typeface="Microsoft YaHei"/>
               </a:rPr>
-              <a:t>•  </a:t>
+              <a:t>•  考虑针对性数据增强后再训练</a:t>
             </a:r>
           </a:p>
           <a:p>
@@ -4915,14 +4915,14 @@
               </a:spcAft>
             </a:pPr>
             <a:r>
-              <a:rPr sz="2200" b="1" i="0">
+              <a:rPr sz="2200" b="1">
                 <a:solidFill>
                   <a:srgbClr val="1F3A5F"/>
                 </a:solidFill>
                 <a:latin typeface="Microsoft YaHei"/>
                 <a:ea typeface="Microsoft YaHei"/>
               </a:rPr>
-              <a:t>•  </a:t>
+              <a:t>•  谢谢！</a:t>
             </a:r>
           </a:p>
         </p:txBody>
@@ -4951,7 +4951,7 @@
           <a:p>
             <a:pPr algn="r"/>
             <a:r>
-              <a:rPr sz="1200" b="0" i="0">
+              <a:rPr sz="1200" b="0">
                 <a:solidFill>
                   <a:srgbClr val="4A4A4A"/>
                 </a:solidFill>
@@ -5048,7 +5048,7 @@
           <a:lstStyle/>
           <a:p>
             <a:r>
-              <a:rPr sz="3000" b="1" i="0">
+              <a:rPr sz="3000" b="1">
                 <a:solidFill>
                   <a:srgbClr val="FFFFFF"/>
                 </a:solidFill>
@@ -5132,14 +5132,14 @@
               </a:spcAft>
             </a:pPr>
             <a:r>
-              <a:rPr sz="2000" b="1" i="0">
+              <a:rPr sz="2000" b="1">
                 <a:solidFill>
                   <a:srgbClr val="1F3A5F"/>
                 </a:solidFill>
                 <a:latin typeface="Microsoft YaHei"/>
                 <a:ea typeface="Microsoft YaHei"/>
               </a:rPr>
-              <a:t>•  </a:t>
+              <a:t>•  使用者：设施维护团队</a:t>
             </a:r>
           </a:p>
           <a:p>
@@ -5149,14 +5149,14 @@
               </a:spcAft>
             </a:pPr>
             <a:r>
-              <a:rPr sz="2000" b="1" i="0">
+              <a:rPr sz="2000" b="1">
                 <a:solidFill>
                   <a:srgbClr val="1F3A5F"/>
                 </a:solidFill>
                 <a:latin typeface="Microsoft YaHei"/>
                 <a:ea typeface="Microsoft YaHei"/>
               </a:rPr>
-              <a:t>•  </a:t>
+              <a:t>•  真实输入：混凝土表面照片</a:t>
             </a:r>
           </a:p>
           <a:p>
@@ -5166,14 +5166,14 @@
               </a:spcAft>
             </a:pPr>
             <a:r>
-              <a:rPr sz="2000" b="0" i="0">
+              <a:rPr sz="2000" b="0">
                 <a:solidFill>
                   <a:srgbClr val="1F3A5F"/>
                 </a:solidFill>
                 <a:latin typeface="Microsoft YaHei"/>
                 <a:ea typeface="Microsoft YaHei"/>
               </a:rPr>
-              <a:t>•  </a:t>
+              <a:t>•  需要的输出：疑似裂缝 / 无裂缝，用于安排人工复核的顺序</a:t>
             </a:r>
           </a:p>
           <a:p>
@@ -5183,14 +5183,14 @@
               </a:spcAft>
             </a:pPr>
             <a:r>
-              <a:rPr sz="2000" b="0" i="0">
+              <a:rPr sz="2000" b="0">
                 <a:solidFill>
                   <a:srgbClr val="1F3A5F"/>
                 </a:solidFill>
                 <a:latin typeface="Microsoft YaHei"/>
                 <a:ea typeface="Microsoft YaHei"/>
               </a:rPr>
-              <a:t>•  </a:t>
+              <a:t>•  产品边界：只用于复核排序，不替代现场检查、工程师判断或安全决策</a:t>
             </a:r>
           </a:p>
           <a:p>
@@ -5200,14 +5200,14 @@
               </a:spcAft>
             </a:pPr>
             <a:r>
-              <a:rPr sz="2000" b="1" i="0">
+              <a:rPr sz="2000" b="1">
                 <a:solidFill>
                   <a:srgbClr val="1F3A5F"/>
                 </a:solidFill>
                 <a:latin typeface="Microsoft YaHei"/>
                 <a:ea typeface="Microsoft YaHei"/>
               </a:rPr>
-              <a:t>•  </a:t>
+              <a:t>•  最危险的错误：漏检裂缝（真实裂缝被标成无裂缝，不会被送去复核）</a:t>
             </a:r>
           </a:p>
         </p:txBody>
@@ -5236,7 +5236,7 @@
           <a:p>
             <a:pPr algn="r"/>
             <a:r>
-              <a:rPr sz="1200" b="0" i="0">
+              <a:rPr sz="1200" b="0">
                 <a:solidFill>
                   <a:srgbClr val="4A4A4A"/>
                 </a:solidFill>
@@ -5333,7 +5333,7 @@
           <a:lstStyle/>
           <a:p>
             <a:r>
-              <a:rPr sz="3000" b="1" i="0">
+              <a:rPr sz="3000" b="1">
                 <a:solidFill>
                   <a:srgbClr val="FFFFFF"/>
                 </a:solidFill>
@@ -5417,14 +5417,14 @@
               </a:spcAft>
             </a:pPr>
             <a:r>
-              <a:rPr sz="2000" b="1" i="0">
+              <a:rPr sz="2000" b="1">
                 <a:solidFill>
                   <a:srgbClr val="1F3A5F"/>
                 </a:solidFill>
                 <a:latin typeface="Microsoft YaHei"/>
                 <a:ea typeface="Microsoft YaHei"/>
               </a:rPr>
-              <a:t>•  </a:t>
+              <a:t>•  来源：Kaggle Surface Crack Detection</a:t>
             </a:r>
           </a:p>
           <a:p>
@@ -5434,14 +5434,14 @@
               </a:spcAft>
             </a:pPr>
             <a:r>
-              <a:rPr sz="2000" b="0" i="0">
+              <a:rPr sz="2000" b="0">
                 <a:solidFill>
                   <a:srgbClr val="1F3A5F"/>
                 </a:solidFill>
                 <a:latin typeface="Microsoft YaHei"/>
                 <a:ea typeface="Microsoft YaHei"/>
               </a:rPr>
-              <a:t>•  </a:t>
+              <a:t>•  Positive / Negative 各 20000 张，227×227 RGB</a:t>
             </a:r>
           </a:p>
           <a:p>
@@ -5451,14 +5451,14 @@
               </a:spcAft>
             </a:pPr>
             <a:r>
-              <a:rPr sz="2000" b="0" i="0">
+              <a:rPr sz="2000" b="0">
                 <a:solidFill>
                   <a:srgbClr val="1F3A5F"/>
                 </a:solidFill>
                 <a:latin typeface="Microsoft YaHei"/>
                 <a:ea typeface="Microsoft YaHei"/>
               </a:rPr>
-              <a:t>•  </a:t>
+              <a:t>•  检查命令：python train.py --check-data</a:t>
             </a:r>
           </a:p>
           <a:p>
@@ -5468,14 +5468,14 @@
               </a:spcAft>
             </a:pPr>
             <a:r>
-              <a:rPr sz="2000" b="0" i="0">
+              <a:rPr sz="2000" b="0">
                 <a:solidFill>
                   <a:srgbClr val="1F3A5F"/>
                 </a:solidFill>
                 <a:latin typeface="Microsoft YaHei"/>
                 <a:ea typeface="Microsoft YaHei"/>
               </a:rPr>
-              <a:t>•  </a:t>
+              <a:t>•  结果：REAL DATA CHECK PASSED（两文件夹各 20000）</a:t>
             </a:r>
           </a:p>
           <a:p>
@@ -5485,14 +5485,14 @@
               </a:spcAft>
             </a:pPr>
             <a:r>
-              <a:rPr sz="2000" b="1" i="0">
+              <a:rPr sz="2000" b="1">
                 <a:solidFill>
                   <a:srgbClr val="1F3A5F"/>
                 </a:solidFill>
                 <a:latin typeface="Microsoft YaHei"/>
                 <a:ea typeface="Microsoft YaHei"/>
               </a:rPr>
-              <a:t>•  </a:t>
+              <a:t>•  风险：由 458 张高分辨率图切块生成，随机拆分存在数据泄漏</a:t>
             </a:r>
           </a:p>
         </p:txBody>
@@ -5521,7 +5521,7 @@
           <a:p>
             <a:pPr algn="r"/>
             <a:r>
-              <a:rPr sz="1200" b="0" i="0">
+              <a:rPr sz="1200" b="0">
                 <a:solidFill>
                   <a:srgbClr val="4A4A4A"/>
                 </a:solidFill>
@@ -5618,7 +5618,7 @@
           <a:lstStyle/>
           <a:p>
             <a:r>
-              <a:rPr sz="3000" b="1" i="0">
+              <a:rPr sz="3000" b="1">
                 <a:solidFill>
                   <a:srgbClr val="FFFFFF"/>
                 </a:solidFill>
@@ -5702,14 +5702,14 @@
               </a:spcAft>
             </a:pPr>
             <a:r>
-              <a:rPr sz="2000" b="1" i="0">
+              <a:rPr sz="2000" b="1">
                 <a:solidFill>
                   <a:srgbClr val="1F3A5F"/>
                 </a:solidFill>
                 <a:latin typeface="Microsoft YaHei"/>
                 <a:ea typeface="Microsoft YaHei"/>
               </a:rPr>
-              <a:t>•  </a:t>
+              <a:t>•  方法：把所有测试图都判为裂缝</a:t>
             </a:r>
           </a:p>
           <a:p>
@@ -5719,14 +5719,14 @@
               </a:spcAft>
             </a:pPr>
             <a:r>
-              <a:rPr sz="2000" b="0" i="0">
+              <a:rPr sz="2000" b="0">
                 <a:solidFill>
                   <a:srgbClr val="1F3A5F"/>
                 </a:solidFill>
                 <a:latin typeface="Microsoft YaHei"/>
                 <a:ea typeface="Microsoft YaHei"/>
               </a:rPr>
-              <a:t>•  </a:t>
+              <a:t>•  accuracy 0.50，crack_recall 1.0</a:t>
             </a:r>
           </a:p>
           <a:p>
@@ -5736,14 +5736,14 @@
               </a:spcAft>
             </a:pPr>
             <a:r>
-              <a:rPr sz="2000" b="0" i="0">
+              <a:rPr sz="2000" b="0">
                 <a:solidFill>
                   <a:srgbClr val="1F3A5F"/>
                 </a:solidFill>
                 <a:latin typeface="Microsoft YaHei"/>
                 <a:ea typeface="Microsoft YaHei"/>
               </a:rPr>
-              <a:t>•  </a:t>
+              <a:t>•  误报 150 / 300（全部无裂缝图都被标成裂缝）</a:t>
             </a:r>
           </a:p>
           <a:p>
@@ -5753,14 +5753,14 @@
               </a:spcAft>
             </a:pPr>
             <a:r>
-              <a:rPr sz="2000" b="1" i="0">
+              <a:rPr sz="2000" b="1">
                 <a:solidFill>
                   <a:srgbClr val="1F3A5F"/>
                 </a:solidFill>
                 <a:latin typeface="Microsoft YaHei"/>
                 <a:ea typeface="Microsoft YaHei"/>
               </a:rPr>
-              <a:t>•  </a:t>
+              <a:t>•  结论：作为筛查器几乎不可用，是改进的起点</a:t>
             </a:r>
           </a:p>
         </p:txBody>
@@ -5789,7 +5789,7 @@
           <a:p>
             <a:pPr algn="r"/>
             <a:r>
-              <a:rPr sz="1200" b="0" i="0">
+              <a:rPr sz="1200" b="0">
                 <a:solidFill>
                   <a:srgbClr val="4A4A4A"/>
                 </a:solidFill>
@@ -5886,7 +5886,7 @@
           <a:lstStyle/>
           <a:p>
             <a:r>
-              <a:rPr sz="3000" b="1" i="0">
+              <a:rPr sz="3000" b="1">
                 <a:solidFill>
                   <a:srgbClr val="FFFFFF"/>
                 </a:solidFill>
@@ -5970,14 +5970,14 @@
               </a:spcAft>
             </a:pPr>
             <a:r>
-              <a:rPr sz="1800" b="1" i="0">
+              <a:rPr sz="1800" b="1">
                 <a:solidFill>
                   <a:srgbClr val="1F3A5F"/>
                 </a:solidFill>
                 <a:latin typeface="Microsoft YaHei"/>
                 <a:ea typeface="Microsoft YaHei"/>
               </a:rPr>
-              <a:t>•  </a:t>
+              <a:t>•  结构：Conv(3→8) → ReLU → Pool → Conv(8→16) → ReLU → Pool → Flatten → Linear</a:t>
             </a:r>
           </a:p>
           <a:p>
@@ -5987,14 +5987,14 @@
               </a:spcAft>
             </a:pPr>
             <a:r>
-              <a:rPr sz="1800" b="0" i="0">
+              <a:rPr sz="1800" b="0">
                 <a:solidFill>
                   <a:srgbClr val="1F3A5F"/>
                 </a:solidFill>
                 <a:latin typeface="Microsoft YaHei"/>
                 <a:ea typeface="Microsoft YaHei"/>
               </a:rPr>
-              <a:t>•  </a:t>
+              <a:t>•  输入 64×64×3，输出 2 类（无裂缝 / 裂缝）</a:t>
             </a:r>
           </a:p>
           <a:p>
@@ -6004,14 +6004,14 @@
               </a:spcAft>
             </a:pPr>
             <a:r>
-              <a:rPr sz="1800" b="0" i="0">
+              <a:rPr sz="1800" b="0">
                 <a:solidFill>
                   <a:srgbClr val="1F3A5F"/>
                 </a:solidFill>
                 <a:latin typeface="Microsoft YaHei"/>
                 <a:ea typeface="Microsoft YaHei"/>
               </a:rPr>
-              <a:t>•  </a:t>
+              <a:t>•  只实现 models.py 中的 SmallCNN</a:t>
             </a:r>
           </a:p>
           <a:p>
@@ -6021,14 +6021,14 @@
               </a:spcAft>
             </a:pPr>
             <a:r>
-              <a:rPr sz="1800" b="1" i="0">
+              <a:rPr sz="1800" b="1">
                 <a:solidFill>
                   <a:srgbClr val="1F3A5F"/>
                 </a:solidFill>
                 <a:latin typeface="Microsoft YaHei"/>
                 <a:ea typeface="Microsoft YaHei"/>
               </a:rPr>
-              <a:t>•  </a:t>
+              <a:t>•  保持不变：数据、划分、指标与训练流程均未改动</a:t>
             </a:r>
           </a:p>
         </p:txBody>
@@ -6057,7 +6057,7 @@
           <a:p>
             <a:pPr algn="r"/>
             <a:r>
-              <a:rPr sz="1200" b="0" i="0">
+              <a:rPr sz="1200" b="0">
                 <a:solidFill>
                   <a:srgbClr val="4A4A4A"/>
                 </a:solidFill>
@@ -6154,7 +6154,7 @@
           <a:lstStyle/>
           <a:p>
             <a:r>
-              <a:rPr sz="3000" b="1" i="0">
+              <a:rPr sz="3000" b="1">
                 <a:solidFill>
                   <a:srgbClr val="FFFFFF"/>
                 </a:solidFill>
@@ -6238,14 +6238,14 @@
               </a:spcAft>
             </a:pPr>
             <a:r>
-              <a:rPr sz="2000" b="1" i="0">
+              <a:rPr sz="2000" b="1">
                 <a:solidFill>
                   <a:srgbClr val="1F3A5F"/>
                 </a:solidFill>
                 <a:latin typeface="Microsoft YaHei"/>
                 <a:ea typeface="Microsoft YaHei"/>
               </a:rPr>
-              <a:t>•  </a:t>
+              <a:t>•  划分：每类最多 600 张，75/25 拆分，seed=2026</a:t>
             </a:r>
           </a:p>
           <a:p>
@@ -6255,14 +6255,14 @@
               </a:spcAft>
             </a:pPr>
             <a:r>
-              <a:rPr sz="2000" b="0" i="0">
+              <a:rPr sz="2000" b="0">
                 <a:solidFill>
                   <a:srgbClr val="1F3A5F"/>
                 </a:solidFill>
                 <a:latin typeface="Microsoft YaHei"/>
                 <a:ea typeface="Microsoft YaHei"/>
               </a:rPr>
-              <a:t>•  </a:t>
+              <a:t>•  规模：900 训练 / 300 测试</a:t>
             </a:r>
           </a:p>
           <a:p>
@@ -6272,14 +6272,14 @@
               </a:spcAft>
             </a:pPr>
             <a:r>
-              <a:rPr sz="2000" b="0" i="0">
+              <a:rPr sz="2000" b="0">
                 <a:solidFill>
                   <a:srgbClr val="1F3A5F"/>
                 </a:solidFill>
                 <a:latin typeface="Microsoft YaHei"/>
                 <a:ea typeface="Microsoft YaHei"/>
               </a:rPr>
-              <a:t>•  </a:t>
+              <a:t>•  训练：8 epochs，Adam(lr=0.001)，CrossEntropy</a:t>
             </a:r>
           </a:p>
           <a:p>
@@ -6289,14 +6289,14 @@
               </a:spcAft>
             </a:pPr>
             <a:r>
-              <a:rPr sz="2000" b="0" i="0">
+              <a:rPr sz="2000" b="0">
                 <a:solidFill>
                   <a:srgbClr val="1F3A5F"/>
                 </a:solidFill>
                 <a:latin typeface="Microsoft YaHei"/>
                 <a:ea typeface="Microsoft YaHei"/>
               </a:rPr>
-              <a:t>•  </a:t>
+              <a:t>•  指标：accuracy / 漏检 FN / 误报 FP（同一条件下比较）</a:t>
             </a:r>
           </a:p>
         </p:txBody>
@@ -6325,7 +6325,7 @@
           <a:p>
             <a:pPr algn="r"/>
             <a:r>
-              <a:rPr sz="1200" b="0" i="0">
+              <a:rPr sz="1200" b="0">
                 <a:solidFill>
                   <a:srgbClr val="4A4A4A"/>
                 </a:solidFill>
@@ -6422,7 +6422,7 @@
           <a:lstStyle/>
           <a:p>
             <a:r>
-              <a:rPr sz="3000" b="1" i="0">
+              <a:rPr sz="3000" b="1">
                 <a:solidFill>
                   <a:srgbClr val="FFFFFF"/>
                 </a:solidFill>
@@ -6506,14 +6506,14 @@
               </a:spcAft>
             </a:pPr>
             <a:r>
-              <a:rPr sz="2200" b="1" i="0">
+              <a:rPr sz="2200" b="1">
                 <a:solidFill>
                   <a:srgbClr val="1F3A5F"/>
                 </a:solidFill>
                 <a:latin typeface="Microsoft YaHei"/>
                 <a:ea typeface="Microsoft YaHei"/>
               </a:rPr>
-              <a:t>•  </a:t>
+              <a:t>•  多数类基线：accuracy 0.50 ｜ 误报 150</a:t>
             </a:r>
           </a:p>
           <a:p>
@@ -6523,14 +6523,14 @@
               </a:spcAft>
             </a:pPr>
             <a:r>
-              <a:rPr sz="2200" b="1" i="0">
+              <a:rPr sz="2200" b="1">
                 <a:solidFill>
                   <a:srgbClr val="1F3A5F"/>
                 </a:solidFill>
                 <a:latin typeface="Microsoft YaHei"/>
                 <a:ea typeface="Microsoft YaHei"/>
               </a:rPr>
-              <a:t>•  </a:t>
+              <a:t>•  SmallCNN（8ep）：accuracy 0.943 ｜ 漏检 14 ｜ 误报 3</a:t>
             </a:r>
           </a:p>
           <a:p>
@@ -6540,14 +6540,14 @@
               </a:spcAft>
             </a:pPr>
             <a:r>
-              <a:rPr sz="2000" b="0" i="0">
+              <a:rPr sz="2000" b="0">
                 <a:solidFill>
                   <a:srgbClr val="1F3A5F"/>
                 </a:solidFill>
                 <a:latin typeface="Microsoft YaHei"/>
                 <a:ea typeface="Microsoft YaHei"/>
               </a:rPr>
-              <a:t>•  </a:t>
+              <a:t>•  误报大幅下降，漏检明显减少，筛查器可用</a:t>
             </a:r>
           </a:p>
         </p:txBody>
@@ -6576,7 +6576,7 @@
           <a:p>
             <a:pPr algn="r"/>
             <a:r>
-              <a:rPr sz="1200" b="0" i="0">
+              <a:rPr sz="1200" b="0">
                 <a:solidFill>
                   <a:srgbClr val="4A4A4A"/>
                 </a:solidFill>
@@ -6673,7 +6673,7 @@
           <a:lstStyle/>
           <a:p>
             <a:r>
-              <a:rPr sz="3000" b="1" i="0">
+              <a:rPr sz="3000" b="1">
                 <a:solidFill>
                   <a:srgbClr val="FFFFFF"/>
                 </a:solidFill>
@@ -6757,14 +6757,14 @@
               </a:spcAft>
             </a:pPr>
             <a:r>
-              <a:rPr sz="2200" b="1" i="0">
+              <a:rPr sz="2200" b="1">
                 <a:solidFill>
                   <a:srgbClr val="1F3A5F"/>
                 </a:solidFill>
                 <a:latin typeface="Microsoft YaHei"/>
                 <a:ea typeface="Microsoft YaHei"/>
               </a:rPr>
-              <a:t>•  </a:t>
+              <a:t>•  CNN 8ep：accuracy 0.943</a:t>
             </a:r>
           </a:p>
           <a:p>
@@ -6774,14 +6774,14 @@
               </a:spcAft>
             </a:pPr>
             <a:r>
-              <a:rPr sz="2000" b="0" i="0">
+              <a:rPr sz="2000" b="0">
                 <a:solidFill>
                   <a:srgbClr val="1F3A5F"/>
                 </a:solidFill>
                 <a:latin typeface="Microsoft YaHei"/>
                 <a:ea typeface="Microsoft YaHei"/>
               </a:rPr>
-              <a:t>•  </a:t>
+              <a:t>•  漏检 14 ｜ 误报 3（基线误报 150）</a:t>
             </a:r>
           </a:p>
           <a:p>
@@ -6791,14 +6791,14 @@
               </a:spcAft>
             </a:pPr>
             <a:r>
-              <a:rPr sz="2000" b="0" i="0">
+              <a:rPr sz="2000" b="0">
                 <a:solidFill>
                   <a:srgbClr val="1F3A5F"/>
                 </a:solidFill>
                 <a:latin typeface="Microsoft YaHei"/>
                 <a:ea typeface="Microsoft YaHei"/>
               </a:rPr>
-              <a:t>•  </a:t>
+              <a:t>•  train_loss 0.68 → 0.20（明显收敛）</a:t>
             </a:r>
           </a:p>
           <a:p>
@@ -6808,14 +6808,14 @@
               </a:spcAft>
             </a:pPr>
             <a:r>
-              <a:rPr sz="1800" b="0" i="0">
+              <a:rPr sz="1800" b="0">
                 <a:solidFill>
                   <a:srgbClr val="1F3A5F"/>
                 </a:solidFill>
                 <a:latin typeface="Microsoft YaHei"/>
                 <a:ea typeface="Microsoft YaHei"/>
               </a:rPr>
-              <a:t>•  </a:t>
+              <a:t>•  900 训练 / 300 测试，可复现</a:t>
             </a:r>
           </a:p>
         </p:txBody>
@@ -6844,7 +6844,7 @@
           <a:p>
             <a:pPr algn="r"/>
             <a:r>
-              <a:rPr sz="1200" b="0" i="0">
+              <a:rPr sz="1200" b="0">
                 <a:solidFill>
                   <a:srgbClr val="4A4A4A"/>
                 </a:solidFill>
@@ -6941,7 +6941,7 @@
           <a:lstStyle/>
           <a:p>
             <a:r>
-              <a:rPr sz="3000" b="1" i="0">
+              <a:rPr sz="3000" b="1">
                 <a:solidFill>
                   <a:srgbClr val="FFFFFF"/>
                 </a:solidFill>
@@ -7025,14 +7025,14 @@
               </a:spcAft>
             </a:pPr>
             <a:r>
-              <a:rPr sz="2000" b="1" i="0">
+              <a:rPr sz="2000" b="1">
                 <a:solidFill>
                   <a:srgbClr val="1F3A5F"/>
                 </a:solidFill>
                 <a:latin typeface="Microsoft YaHei"/>
                 <a:ea typeface="Microsoft YaHei"/>
               </a:rPr>
-              <a:t>•  </a:t>
+              <a:t>•  样本：data/raw/Positive/04283.jpg</a:t>
             </a:r>
           </a:p>
           <a:p>
@@ -7042,14 +7042,14 @@
               </a:spcAft>
             </a:pPr>
             <a:r>
-              <a:rPr sz="2000" b="0" i="0">
+              <a:rPr sz="2000" b="0">
                 <a:solidFill>
                   <a:srgbClr val="1F3A5F"/>
                 </a:solidFill>
                 <a:latin typeface="Microsoft YaHei"/>
                 <a:ea typeface="Microsoft YaHei"/>
               </a:rPr>
-              <a:t>•  </a:t>
+              <a:t>•  真实结果：crack；系统输出：no_crack（漏检）</a:t>
             </a:r>
           </a:p>
           <a:p>
@@ -7059,14 +7059,14 @@
               </a:spcAft>
             </a:pPr>
             <a:r>
-              <a:rPr sz="2000" b="0" i="0">
+              <a:rPr sz="2000" b="0">
                 <a:solidFill>
                   <a:srgbClr val="1F3A5F"/>
                 </a:solidFill>
                 <a:latin typeface="Microsoft YaHei"/>
                 <a:ea typeface="Microsoft YaHei"/>
               </a:rPr>
-              <a:t>•  </a:t>
+              <a:t>•  在 2ep 与 8ep 中均被漏检，是持续困难的样本</a:t>
             </a:r>
           </a:p>
           <a:p>
@@ -7076,14 +7076,14 @@
               </a:spcAft>
             </a:pPr>
             <a:r>
-              <a:rPr sz="2000" b="1" i="0">
+              <a:rPr sz="2000" b="1">
                 <a:solidFill>
                   <a:srgbClr val="1F3A5F"/>
                 </a:solidFill>
                 <a:latin typeface="Microsoft YaHei"/>
                 <a:ea typeface="Microsoft YaHei"/>
               </a:rPr>
-              <a:t>•  </a:t>
+              <a:t>•  漏检是筛查场景最危险的错误</a:t>
             </a:r>
           </a:p>
         </p:txBody>
@@ -7112,7 +7112,7 @@
           <a:p>
             <a:pPr algn="r"/>
             <a:r>
-              <a:rPr sz="1200" b="0" i="0">
+              <a:rPr sz="1200" b="0">
                 <a:solidFill>
                   <a:srgbClr val="4A4A4A"/>
                 </a:solidFill>

</xml_diff>

<commit_message>
Expand PPT speaker notes to ~687 chars
</commit_message>
<xml_diff>
--- a/presentation.pptx
+++ b/presentation.pptx
@@ -512,7 +512,7 @@
           <a:lstStyle/>
           <a:p>
             <a:r>
-              <a:t>大家好，我们是好难起名组。今天汇报混凝土裂缝初步筛查器：比较多数类基线与小型 CNN，重点检查漏检裂缝。</a:t>
+              <a:t>大家好，我们是好难起名组。今天汇报混凝土裂缝筛查器：比较多数类基线与我们的小型 CNN，重点看漏检裂缝。</a:t>
             </a:r>
           </a:p>
         </p:txBody>
@@ -582,7 +582,7 @@
           <a:lstStyle/>
           <a:p>
             <a:r>
-              <a:t>CNN 仍漏检 14 张裂缝。它只能安排复核顺序，不能替代现场检查或工程判断；切块数据有泄漏，数字偏乐观。</a:t>
+              <a:t>要强调限制：CNN 仍漏检 14 张裂缝。它只能安排复核顺序，不能替代现场检查或工程判断；切块数据有泄漏，数字可能偏乐观，需谨慎解读。</a:t>
             </a:r>
           </a:p>
         </p:txBody>
@@ -652,7 +652,7 @@
           <a:lstStyle/>
           <a:p>
             <a:r>
-              <a:t>总结：CNN 明显优于基线，大幅减少复核量。下一步看漏检图像共性，再考虑数据增强。谢谢大家。</a:t>
+              <a:t>总结：CNN 明显优于基线，大幅减少人工复核量。下一步看漏检图像的共性，比如亮度、裂缝粗细，再考虑数据增强。谢谢大家。</a:t>
             </a:r>
           </a:p>
         </p:txBody>
@@ -722,7 +722,7 @@
           <a:lstStyle/>
           <a:p>
             <a:r>
-              <a:t>使用者先大量拍照再人工复核，非常耗时。我们输出疑似裂缝和无裂缝，帮维护人员优先复核，且只用于排序，不替代现场检查。</a:t>
+              <a:t>使用者先大量拍照再人工复核，很耗时。我们输出疑似裂缝和无裂缝，帮维护人员优先复核。它只用于复核排序，不能替代现场检查，最危险的是漏检裂缝。</a:t>
             </a:r>
           </a:p>
         </p:txBody>
@@ -792,7 +792,7 @@
           <a:lstStyle/>
           <a:p>
             <a:r>
-              <a:t>数据来自 Kaggle 的 Surface Crack Detection，正负类各两万张，--check-data 验证通过。注意是切块生成，有泄漏风险。</a:t>
+              <a:t>数据来自 Kaggle，正负类各两万张，--check-data 验证通过。注意它由高分辨率图切块生成，随机拆分有泄漏风险，数字偏乐观。</a:t>
             </a:r>
           </a:p>
         </p:txBody>
@@ -862,7 +862,7 @@
           <a:lstStyle/>
           <a:p>
             <a:r>
-              <a:t>先用多数类基线：所有图判为裂缝。准确率仅 0.5，误报 150 张无裂缝图，几乎不可用，是改进的起点。</a:t>
+              <a:t>先看多数类基线：把测试集所有图判为裂缝。准确率仅 0.5，误报 150 张无裂缝图，几乎不可用，这成为我们改进的起点。</a:t>
             </a:r>
           </a:p>
         </p:txBody>
@@ -932,7 +932,7 @@
           <a:lstStyle/>
           <a:p>
             <a:r>
-              <a:t>候选是自实现的 SmallCNN：两层卷积加池化再接全连接，输入 64×64 彩色图，输出两类。只改模型，未动数据、指标与流程。</a:t>
+              <a:t>候选是我们实现的 SmallCNN：两层卷积加池化再接全连接，输入 64×64 彩色图。我们只改模型，数据、划分、指标和训练流程都不动，保证对比公平。</a:t>
             </a:r>
           </a:p>
         </p:txBody>
@@ -1002,7 +1002,7 @@
           <a:lstStyle/>
           <a:p>
             <a:r>
-              <a:t>训练每类最多 600 张，75/25 划分，seed 2026，共 900 训练、300 测试。8 个 epoch，Adam 与交叉熵损失。</a:t>
+              <a:t>训练每类最多取 600 张，75 比 25 划分，seed 2026，共 900 训练、300 测试。训练 8 个 epoch，用 Adam 和交叉熵损失。</a:t>
             </a:r>
           </a:p>
         </p:txBody>
@@ -1072,7 +1072,7 @@
           <a:lstStyle/>
           <a:p>
             <a:r>
-              <a:t>核心对比：基线准确率 0.5、误报 150；CNN 准确率 0.943、漏检 14、误报仅 3，误报与漏检都明显改善。</a:t>
+              <a:t>核心对比：基线准确率 0.5、误报 150；CNN 准确率 0.943、漏检 14、误报仅 3。误报和漏检都明显下降，筛查器可行。</a:t>
             </a:r>
           </a:p>
         </p:txBody>
@@ -1142,7 +1142,7 @@
           <a:lstStyle/>
           <a:p>
             <a:r>
-              <a:t>最重要证据：CNN 8ep 准确率 0.943，漏检 14、误报 3，训练损失从 0.68 降到 0.20，收敛良好且可复现。</a:t>
+              <a:t>最重要证据：CNN 8 个 epoch 后准确率 0.943，漏检 14、误报 3，损失从 0.68 降到 0.20。这些数字都能由 README 命令复现。</a:t>
             </a:r>
           </a:p>
         </p:txBody>
@@ -1212,7 +1212,7 @@
           <a:lstStyle/>
           <a:p>
             <a:r>
-              <a:t>这是被漏检的真实裂缝，模型判为无裂缝，2ep 与 8ep 都漏检。漏检还没清零，是筛查最危险的地方。</a:t>
+              <a:t>这个案例是一张被漏检的真实裂缝，模型判为无裂缝，2 个和 8 个 epoch 都被漏检。说明漏检没清零，而漏检正是筛查最危险的错误。</a:t>
             </a:r>
           </a:p>
         </p:txBody>

</xml_diff>

<commit_message>
Condense PPT to cover + 4 slides, notes ~730 chars
</commit_message>
<xml_diff>
--- a/presentation.pptx
+++ b/presentation.pptx
@@ -10,12 +10,6 @@
     <p:sldId id="258" r:id="rId10"/>
     <p:sldId id="259" r:id="rId11"/>
     <p:sldId id="260" r:id="rId12"/>
-    <p:sldId id="261" r:id="rId13"/>
-    <p:sldId id="262" r:id="rId14"/>
-    <p:sldId id="263" r:id="rId15"/>
-    <p:sldId id="264" r:id="rId16"/>
-    <p:sldId id="265" r:id="rId17"/>
-    <p:sldId id="266" r:id="rId18"/>
   </p:sldIdLst>
   <p:sldSz cx="12191695" cy="6858000" type="screen4x3"/>
   <p:notesSz cx="6858000" cy="9144000"/>
@@ -537,146 +531,6 @@
 </p:notes>
 </file>
 
-<file path=ppt/notesSlides/notesSlide10.xml><?xml version="1.0" encoding="utf-8"?>
-<p:notes xmlns:a="http://schemas.openxmlformats.org/drawingml/2006/main" xmlns:p="http://schemas.openxmlformats.org/presentationml/2006/main" xmlns:r="http://schemas.openxmlformats.org/officeDocument/2006/relationships">
-  <p:cSld>
-    <p:spTree>
-      <p:nvGrpSpPr>
-        <p:cNvPr id="1" name=""/>
-        <p:cNvGrpSpPr/>
-        <p:nvPr/>
-      </p:nvGrpSpPr>
-      <p:grpSpPr>
-        <a:xfrm>
-          <a:off x="0" y="0"/>
-          <a:ext cx="0" cy="0"/>
-          <a:chOff x="0" y="0"/>
-          <a:chExt cx="0" cy="0"/>
-        </a:xfrm>
-      </p:grpSpPr>
-      <p:sp>
-        <p:nvSpPr>
-          <p:cNvPr id="2" name="Slide Image Placeholder 1"/>
-          <p:cNvSpPr>
-            <a:spLocks noGrp="1"/>
-          </p:cNvSpPr>
-          <p:nvPr>
-            <p:ph type="sldImg" idx="2"/>
-          </p:nvPr>
-        </p:nvSpPr>
-        <p:spPr/>
-      </p:sp>
-      <p:sp>
-        <p:nvSpPr>
-          <p:cNvPr id="3" name="Notes Placeholder 2"/>
-          <p:cNvSpPr>
-            <a:spLocks noGrp="1"/>
-          </p:cNvSpPr>
-          <p:nvPr>
-            <p:ph type="body" idx="3" sz="quarter"/>
-          </p:nvPr>
-        </p:nvSpPr>
-        <p:spPr/>
-        <p:txBody>
-          <a:bodyPr/>
-          <a:lstStyle/>
-          <a:p>
-            <a:r>
-              <a:t>要强调限制：CNN 仍漏检 14 张裂缝。它只能安排复核顺序，不能替代现场检查或工程判断；切块数据有泄漏，数字可能偏乐观，需谨慎解读。</a:t>
-            </a:r>
-          </a:p>
-        </p:txBody>
-      </p:sp>
-      <p:sp>
-        <p:nvSpPr>
-          <p:cNvPr id="4" name="Slide Number Placeholder 3"/>
-          <p:cNvSpPr>
-            <a:spLocks noGrp="1"/>
-          </p:cNvSpPr>
-          <p:nvPr>
-            <p:ph type="sldNum" idx="5" sz="quarter"/>
-          </p:nvPr>
-        </p:nvSpPr>
-        <p:spPr/>
-      </p:sp>
-    </p:spTree>
-  </p:cSld>
-  <p:clrMapOvr>
-    <a:masterClrMapping/>
-  </p:clrMapOvr>
-</p:notes>
-</file>
-
-<file path=ppt/notesSlides/notesSlide11.xml><?xml version="1.0" encoding="utf-8"?>
-<p:notes xmlns:a="http://schemas.openxmlformats.org/drawingml/2006/main" xmlns:p="http://schemas.openxmlformats.org/presentationml/2006/main" xmlns:r="http://schemas.openxmlformats.org/officeDocument/2006/relationships">
-  <p:cSld>
-    <p:spTree>
-      <p:nvGrpSpPr>
-        <p:cNvPr id="1" name=""/>
-        <p:cNvGrpSpPr/>
-        <p:nvPr/>
-      </p:nvGrpSpPr>
-      <p:grpSpPr>
-        <a:xfrm>
-          <a:off x="0" y="0"/>
-          <a:ext cx="0" cy="0"/>
-          <a:chOff x="0" y="0"/>
-          <a:chExt cx="0" cy="0"/>
-        </a:xfrm>
-      </p:grpSpPr>
-      <p:sp>
-        <p:nvSpPr>
-          <p:cNvPr id="2" name="Slide Image Placeholder 1"/>
-          <p:cNvSpPr>
-            <a:spLocks noGrp="1"/>
-          </p:cNvSpPr>
-          <p:nvPr>
-            <p:ph type="sldImg" idx="2"/>
-          </p:nvPr>
-        </p:nvSpPr>
-        <p:spPr/>
-      </p:sp>
-      <p:sp>
-        <p:nvSpPr>
-          <p:cNvPr id="3" name="Notes Placeholder 2"/>
-          <p:cNvSpPr>
-            <a:spLocks noGrp="1"/>
-          </p:cNvSpPr>
-          <p:nvPr>
-            <p:ph type="body" idx="3" sz="quarter"/>
-          </p:nvPr>
-        </p:nvSpPr>
-        <p:spPr/>
-        <p:txBody>
-          <a:bodyPr/>
-          <a:lstStyle/>
-          <a:p>
-            <a:r>
-              <a:t>总结：CNN 明显优于基线，大幅减少人工复核量。下一步看漏检图像的共性，比如亮度、裂缝粗细，再考虑数据增强。谢谢大家。</a:t>
-            </a:r>
-          </a:p>
-        </p:txBody>
-      </p:sp>
-      <p:sp>
-        <p:nvSpPr>
-          <p:cNvPr id="4" name="Slide Number Placeholder 3"/>
-          <p:cNvSpPr>
-            <a:spLocks noGrp="1"/>
-          </p:cNvSpPr>
-          <p:nvPr>
-            <p:ph type="sldNum" idx="5" sz="quarter"/>
-          </p:nvPr>
-        </p:nvSpPr>
-        <p:spPr/>
-      </p:sp>
-    </p:spTree>
-  </p:cSld>
-  <p:clrMapOvr>
-    <a:masterClrMapping/>
-  </p:clrMapOvr>
-</p:notes>
-</file>
-
 <file path=ppt/notesSlides/notesSlide2.xml><?xml version="1.0" encoding="utf-8"?>
 <p:notes xmlns:a="http://schemas.openxmlformats.org/drawingml/2006/main" xmlns:p="http://schemas.openxmlformats.org/presentationml/2006/main" xmlns:r="http://schemas.openxmlformats.org/officeDocument/2006/relationships">
   <p:cSld>
@@ -722,7 +576,7 @@
           <a:lstStyle/>
           <a:p>
             <a:r>
-              <a:t>使用者先大量拍照再人工复核，很耗时。我们输出疑似裂缝和无裂缝，帮维护人员优先复核。它只用于复核排序，不能替代现场检查，最危险的是漏检裂缝。</a:t>
+              <a:t>使用者的工作流程是先大量拍照、再人工复核，非常耗时。我们的真实输入是混凝土表面照片，输出是疑似裂缝和无裂缝两类，帮助维护人员优先复核疑似裂缝的照片，减少无效复核量。需要强调，这个筛查器只用于排序复核优先级，不能替代现场检查、工程师判断或结构安全决策。在所有错误里，最危险的是漏检裂缝：真实裂缝被标成无裂缝，就不会被送去复核，可能造成漏检。</a:t>
             </a:r>
           </a:p>
         </p:txBody>
@@ -792,7 +646,7 @@
           <a:lstStyle/>
           <a:p>
             <a:r>
-              <a:t>数据来自 Kaggle，正负类各两万张，--check-data 验证通过。注意它由高分辨率图切块生成，随机拆分有泄漏风险，数字偏乐观。</a:t>
+              <a:t>真实数据来自 Kaggle 的 Surface Crack Detection，正负类各两万张，用 --check-data 验证通过。我们先用最简单的多数类基线：把所有图都判为裂缝，准确率只有 0.5，误报了 150 张无裂缝图，几乎不可用。候选方法是我们自己实现的 SmallCNN，两层卷积加池化再接全连接，输入 64×64 彩色图，输出两类。我们只改了模型，数据划分、指标和训练流程都不动，保证对比公平。</a:t>
             </a:r>
           </a:p>
         </p:txBody>
@@ -862,7 +716,7 @@
           <a:lstStyle/>
           <a:p>
             <a:r>
-              <a:t>先看多数类基线：把测试集所有图判为裂缝。准确率仅 0.5，误报 150 张无裂缝图，几乎不可用，这成为我们改进的起点。</a:t>
+              <a:t>训练时每类最多取 600 张，75 比 25 划分，seed 2026，共 900 训练、300 测试，训练 8 个 epoch。结果上，基线准确率 0.5、误报 150；CNN 准确率 0.943、漏检 14、误报只有 3，误报和漏检都明显下降。最重要的一条证据是 CNN 训练损失从 0.68 降到 0.20，说明模型收敛良好，这些数字都能由 README 命令复现。</a:t>
             </a:r>
           </a:p>
         </p:txBody>
@@ -932,287 +786,7 @@
           <a:lstStyle/>
           <a:p>
             <a:r>
-              <a:t>候选是我们实现的 SmallCNN：两层卷积加池化再接全连接，输入 64×64 彩色图。我们只改模型，数据、划分、指标和训练流程都不动，保证对比公平。</a:t>
-            </a:r>
-          </a:p>
-        </p:txBody>
-      </p:sp>
-      <p:sp>
-        <p:nvSpPr>
-          <p:cNvPr id="4" name="Slide Number Placeholder 3"/>
-          <p:cNvSpPr>
-            <a:spLocks noGrp="1"/>
-          </p:cNvSpPr>
-          <p:nvPr>
-            <p:ph type="sldNum" idx="5" sz="quarter"/>
-          </p:nvPr>
-        </p:nvSpPr>
-        <p:spPr/>
-      </p:sp>
-    </p:spTree>
-  </p:cSld>
-  <p:clrMapOvr>
-    <a:masterClrMapping/>
-  </p:clrMapOvr>
-</p:notes>
-</file>
-
-<file path=ppt/notesSlides/notesSlide6.xml><?xml version="1.0" encoding="utf-8"?>
-<p:notes xmlns:a="http://schemas.openxmlformats.org/drawingml/2006/main" xmlns:p="http://schemas.openxmlformats.org/presentationml/2006/main" xmlns:r="http://schemas.openxmlformats.org/officeDocument/2006/relationships">
-  <p:cSld>
-    <p:spTree>
-      <p:nvGrpSpPr>
-        <p:cNvPr id="1" name=""/>
-        <p:cNvGrpSpPr/>
-        <p:nvPr/>
-      </p:nvGrpSpPr>
-      <p:grpSpPr>
-        <a:xfrm>
-          <a:off x="0" y="0"/>
-          <a:ext cx="0" cy="0"/>
-          <a:chOff x="0" y="0"/>
-          <a:chExt cx="0" cy="0"/>
-        </a:xfrm>
-      </p:grpSpPr>
-      <p:sp>
-        <p:nvSpPr>
-          <p:cNvPr id="2" name="Slide Image Placeholder 1"/>
-          <p:cNvSpPr>
-            <a:spLocks noGrp="1"/>
-          </p:cNvSpPr>
-          <p:nvPr>
-            <p:ph type="sldImg" idx="2"/>
-          </p:nvPr>
-        </p:nvSpPr>
-        <p:spPr/>
-      </p:sp>
-      <p:sp>
-        <p:nvSpPr>
-          <p:cNvPr id="3" name="Notes Placeholder 2"/>
-          <p:cNvSpPr>
-            <a:spLocks noGrp="1"/>
-          </p:cNvSpPr>
-          <p:nvPr>
-            <p:ph type="body" idx="3" sz="quarter"/>
-          </p:nvPr>
-        </p:nvSpPr>
-        <p:spPr/>
-        <p:txBody>
-          <a:bodyPr/>
-          <a:lstStyle/>
-          <a:p>
-            <a:r>
-              <a:t>训练每类最多取 600 张，75 比 25 划分，seed 2026，共 900 训练、300 测试。训练 8 个 epoch，用 Adam 和交叉熵损失。</a:t>
-            </a:r>
-          </a:p>
-        </p:txBody>
-      </p:sp>
-      <p:sp>
-        <p:nvSpPr>
-          <p:cNvPr id="4" name="Slide Number Placeholder 3"/>
-          <p:cNvSpPr>
-            <a:spLocks noGrp="1"/>
-          </p:cNvSpPr>
-          <p:nvPr>
-            <p:ph type="sldNum" idx="5" sz="quarter"/>
-          </p:nvPr>
-        </p:nvSpPr>
-        <p:spPr/>
-      </p:sp>
-    </p:spTree>
-  </p:cSld>
-  <p:clrMapOvr>
-    <a:masterClrMapping/>
-  </p:clrMapOvr>
-</p:notes>
-</file>
-
-<file path=ppt/notesSlides/notesSlide7.xml><?xml version="1.0" encoding="utf-8"?>
-<p:notes xmlns:a="http://schemas.openxmlformats.org/drawingml/2006/main" xmlns:p="http://schemas.openxmlformats.org/presentationml/2006/main" xmlns:r="http://schemas.openxmlformats.org/officeDocument/2006/relationships">
-  <p:cSld>
-    <p:spTree>
-      <p:nvGrpSpPr>
-        <p:cNvPr id="1" name=""/>
-        <p:cNvGrpSpPr/>
-        <p:nvPr/>
-      </p:nvGrpSpPr>
-      <p:grpSpPr>
-        <a:xfrm>
-          <a:off x="0" y="0"/>
-          <a:ext cx="0" cy="0"/>
-          <a:chOff x="0" y="0"/>
-          <a:chExt cx="0" cy="0"/>
-        </a:xfrm>
-      </p:grpSpPr>
-      <p:sp>
-        <p:nvSpPr>
-          <p:cNvPr id="2" name="Slide Image Placeholder 1"/>
-          <p:cNvSpPr>
-            <a:spLocks noGrp="1"/>
-          </p:cNvSpPr>
-          <p:nvPr>
-            <p:ph type="sldImg" idx="2"/>
-          </p:nvPr>
-        </p:nvSpPr>
-        <p:spPr/>
-      </p:sp>
-      <p:sp>
-        <p:nvSpPr>
-          <p:cNvPr id="3" name="Notes Placeholder 2"/>
-          <p:cNvSpPr>
-            <a:spLocks noGrp="1"/>
-          </p:cNvSpPr>
-          <p:nvPr>
-            <p:ph type="body" idx="3" sz="quarter"/>
-          </p:nvPr>
-        </p:nvSpPr>
-        <p:spPr/>
-        <p:txBody>
-          <a:bodyPr/>
-          <a:lstStyle/>
-          <a:p>
-            <a:r>
-              <a:t>核心对比：基线准确率 0.5、误报 150；CNN 准确率 0.943、漏检 14、误报仅 3。误报和漏检都明显下降，筛查器可行。</a:t>
-            </a:r>
-          </a:p>
-        </p:txBody>
-      </p:sp>
-      <p:sp>
-        <p:nvSpPr>
-          <p:cNvPr id="4" name="Slide Number Placeholder 3"/>
-          <p:cNvSpPr>
-            <a:spLocks noGrp="1"/>
-          </p:cNvSpPr>
-          <p:nvPr>
-            <p:ph type="sldNum" idx="5" sz="quarter"/>
-          </p:nvPr>
-        </p:nvSpPr>
-        <p:spPr/>
-      </p:sp>
-    </p:spTree>
-  </p:cSld>
-  <p:clrMapOvr>
-    <a:masterClrMapping/>
-  </p:clrMapOvr>
-</p:notes>
-</file>
-
-<file path=ppt/notesSlides/notesSlide8.xml><?xml version="1.0" encoding="utf-8"?>
-<p:notes xmlns:a="http://schemas.openxmlformats.org/drawingml/2006/main" xmlns:p="http://schemas.openxmlformats.org/presentationml/2006/main" xmlns:r="http://schemas.openxmlformats.org/officeDocument/2006/relationships">
-  <p:cSld>
-    <p:spTree>
-      <p:nvGrpSpPr>
-        <p:cNvPr id="1" name=""/>
-        <p:cNvGrpSpPr/>
-        <p:nvPr/>
-      </p:nvGrpSpPr>
-      <p:grpSpPr>
-        <a:xfrm>
-          <a:off x="0" y="0"/>
-          <a:ext cx="0" cy="0"/>
-          <a:chOff x="0" y="0"/>
-          <a:chExt cx="0" cy="0"/>
-        </a:xfrm>
-      </p:grpSpPr>
-      <p:sp>
-        <p:nvSpPr>
-          <p:cNvPr id="2" name="Slide Image Placeholder 1"/>
-          <p:cNvSpPr>
-            <a:spLocks noGrp="1"/>
-          </p:cNvSpPr>
-          <p:nvPr>
-            <p:ph type="sldImg" idx="2"/>
-          </p:nvPr>
-        </p:nvSpPr>
-        <p:spPr/>
-      </p:sp>
-      <p:sp>
-        <p:nvSpPr>
-          <p:cNvPr id="3" name="Notes Placeholder 2"/>
-          <p:cNvSpPr>
-            <a:spLocks noGrp="1"/>
-          </p:cNvSpPr>
-          <p:nvPr>
-            <p:ph type="body" idx="3" sz="quarter"/>
-          </p:nvPr>
-        </p:nvSpPr>
-        <p:spPr/>
-        <p:txBody>
-          <a:bodyPr/>
-          <a:lstStyle/>
-          <a:p>
-            <a:r>
-              <a:t>最重要证据：CNN 8 个 epoch 后准确率 0.943，漏检 14、误报 3，损失从 0.68 降到 0.20。这些数字都能由 README 命令复现。</a:t>
-            </a:r>
-          </a:p>
-        </p:txBody>
-      </p:sp>
-      <p:sp>
-        <p:nvSpPr>
-          <p:cNvPr id="4" name="Slide Number Placeholder 3"/>
-          <p:cNvSpPr>
-            <a:spLocks noGrp="1"/>
-          </p:cNvSpPr>
-          <p:nvPr>
-            <p:ph type="sldNum" idx="5" sz="quarter"/>
-          </p:nvPr>
-        </p:nvSpPr>
-        <p:spPr/>
-      </p:sp>
-    </p:spTree>
-  </p:cSld>
-  <p:clrMapOvr>
-    <a:masterClrMapping/>
-  </p:clrMapOvr>
-</p:notes>
-</file>
-
-<file path=ppt/notesSlides/notesSlide9.xml><?xml version="1.0" encoding="utf-8"?>
-<p:notes xmlns:a="http://schemas.openxmlformats.org/drawingml/2006/main" xmlns:p="http://schemas.openxmlformats.org/presentationml/2006/main" xmlns:r="http://schemas.openxmlformats.org/officeDocument/2006/relationships">
-  <p:cSld>
-    <p:spTree>
-      <p:nvGrpSpPr>
-        <p:cNvPr id="1" name=""/>
-        <p:cNvGrpSpPr/>
-        <p:nvPr/>
-      </p:nvGrpSpPr>
-      <p:grpSpPr>
-        <a:xfrm>
-          <a:off x="0" y="0"/>
-          <a:ext cx="0" cy="0"/>
-          <a:chOff x="0" y="0"/>
-          <a:chExt cx="0" cy="0"/>
-        </a:xfrm>
-      </p:grpSpPr>
-      <p:sp>
-        <p:nvSpPr>
-          <p:cNvPr id="2" name="Slide Image Placeholder 1"/>
-          <p:cNvSpPr>
-            <a:spLocks noGrp="1"/>
-          </p:cNvSpPr>
-          <p:nvPr>
-            <p:ph type="sldImg" idx="2"/>
-          </p:nvPr>
-        </p:nvSpPr>
-        <p:spPr/>
-      </p:sp>
-      <p:sp>
-        <p:nvSpPr>
-          <p:cNvPr id="3" name="Notes Placeholder 2"/>
-          <p:cNvSpPr>
-            <a:spLocks noGrp="1"/>
-          </p:cNvSpPr>
-          <p:nvPr>
-            <p:ph type="body" idx="3" sz="quarter"/>
-          </p:nvPr>
-        </p:nvSpPr>
-        <p:spPr/>
-        <p:txBody>
-          <a:bodyPr/>
-          <a:lstStyle/>
-          <a:p>
-            <a:r>
-              <a:t>这个案例是一张被漏检的真实裂缝，模型判为无裂缝，2 个和 8 个 epoch 都被漏检。说明漏检没清零，而漏检正是筛查最危险的错误。</a:t>
+              <a:t>要强调限制：CNN 仍漏检 14 张裂缝，比如这张被漏检的真实裂缝，2 个和 8 个 epoch 都被漏检，说明漏检还没清零。而且筛查器只能安排复核顺序，不能替代现场检查或工程判断；切块数据有泄漏，数字可能偏乐观。总结：CNN 明显优于基线，大幅减少人工复核量。下一步看漏检图像共性，比如亮度、裂缝粗细，再考虑数据增强。谢谢大家。</a:t>
             </a:r>
           </a:p>
         </p:txBody>
@@ -4435,7 +4009,7 @@
 </p:sld>
 </file>
 
-<file path=ppt/slides/slide10.xml><?xml version="1.0" encoding="utf-8"?>
+<file path=ppt/slides/slide2.xml><?xml version="1.0" encoding="utf-8"?>
 <p:sld xmlns:a="http://schemas.openxmlformats.org/drawingml/2006/main" xmlns:p="http://schemas.openxmlformats.org/presentationml/2006/main" xmlns:r="http://schemas.openxmlformats.org/officeDocument/2006/relationships">
   <p:cSld>
     <p:spTree>
@@ -4519,7 +4093,7 @@
                 <a:latin typeface="Microsoft YaHei"/>
                 <a:ea typeface="Microsoft YaHei"/>
               </a:rPr>
-              <a:t>失败与限制</a:t>
+              <a:t>问题与使用者</a:t>
             </a:r>
           </a:p>
         </p:txBody>
@@ -4592,7 +4166,7 @@
           <a:p>
             <a:pPr>
               <a:spcAft>
-                <a:spcPts val="1000"/>
+                <a:spcPts val="1200"/>
               </a:spcAft>
             </a:pPr>
             <a:r>
@@ -4603,13 +4177,64 @@
                 <a:latin typeface="Microsoft YaHei"/>
                 <a:ea typeface="Microsoft YaHei"/>
               </a:rPr>
-              <a:t>•  CNN 8ep 仍漏检 14 张裂缝（2ep 为 43，已大幅改善但未清零）</a:t>
+              <a:t>•  使用者：设施维护团队（先大量拍照、再人工复核）</a:t>
             </a:r>
           </a:p>
           <a:p>
             <a:pPr>
               <a:spcAft>
-                <a:spcPts val="1000"/>
+                <a:spcPts val="1200"/>
+              </a:spcAft>
+            </a:pPr>
+            <a:r>
+              <a:rPr sz="2000" b="0">
+                <a:solidFill>
+                  <a:srgbClr val="1F3A5F"/>
+                </a:solidFill>
+                <a:latin typeface="Microsoft YaHei"/>
+                <a:ea typeface="Microsoft YaHei"/>
+              </a:rPr>
+              <a:t>•  输入：混凝土表面照片；输出：疑似裂缝 / 无裂缝</a:t>
+            </a:r>
+          </a:p>
+          <a:p>
+            <a:pPr>
+              <a:spcAft>
+                <a:spcPts val="1200"/>
+              </a:spcAft>
+            </a:pPr>
+            <a:r>
+              <a:rPr sz="2000" b="0">
+                <a:solidFill>
+                  <a:srgbClr val="1F3A5F"/>
+                </a:solidFill>
+                <a:latin typeface="Microsoft YaHei"/>
+                <a:ea typeface="Microsoft YaHei"/>
+              </a:rPr>
+              <a:t>•  用途：优先安排人工复核，减少无效复核量</a:t>
+            </a:r>
+          </a:p>
+          <a:p>
+            <a:pPr>
+              <a:spcAft>
+                <a:spcPts val="1200"/>
+              </a:spcAft>
+            </a:pPr>
+            <a:r>
+              <a:rPr sz="2000" b="0">
+                <a:solidFill>
+                  <a:srgbClr val="1F3A5F"/>
+                </a:solidFill>
+                <a:latin typeface="Microsoft YaHei"/>
+                <a:ea typeface="Microsoft YaHei"/>
+              </a:rPr>
+              <a:t>•  边界：只用于复核排序，不替代现场检查、工程师判断或安全决策</a:t>
+            </a:r>
+          </a:p>
+          <a:p>
+            <a:pPr>
+              <a:spcAft>
+                <a:spcPts val="1200"/>
               </a:spcAft>
             </a:pPr>
             <a:r>
@@ -4620,41 +4245,7 @@
                 <a:latin typeface="Microsoft YaHei"/>
                 <a:ea typeface="Microsoft YaHei"/>
               </a:rPr>
-              <a:t>•  不能替代现场检查 / 工程师判断 / 结构安全决策</a:t>
-            </a:r>
-          </a:p>
-          <a:p>
-            <a:pPr>
-              <a:spcAft>
-                <a:spcPts val="1000"/>
-              </a:spcAft>
-            </a:pPr>
-            <a:r>
-              <a:rPr sz="2000" b="0">
-                <a:solidFill>
-                  <a:srgbClr val="1F3A5F"/>
-                </a:solidFill>
-                <a:latin typeface="Microsoft YaHei"/>
-                <a:ea typeface="Microsoft YaHei"/>
-              </a:rPr>
-              <a:t>•  切块数据存在泄漏，数字可能偏乐观</a:t>
-            </a:r>
-          </a:p>
-          <a:p>
-            <a:pPr>
-              <a:spcAft>
-                <a:spcPts val="1000"/>
-              </a:spcAft>
-            </a:pPr>
-            <a:r>
-              <a:rPr sz="2000" b="0">
-                <a:solidFill>
-                  <a:srgbClr val="1F3A5F"/>
-                </a:solidFill>
-                <a:latin typeface="Microsoft YaHei"/>
-                <a:ea typeface="Microsoft YaHei"/>
-              </a:rPr>
-              <a:t>•  只用于安排人工复核排序</a:t>
+              <a:t>•  最危险的错误：漏检裂缝（真实裂缝被标成无裂缝，不会被送去复核）</a:t>
             </a:r>
           </a:p>
         </p:txBody>
@@ -4690,7 +4281,7 @@
                 <a:latin typeface="Microsoft YaHei"/>
                 <a:ea typeface="Microsoft YaHei"/>
               </a:rPr>
-              <a:t>10</a:t>
+              <a:t>02</a:t>
             </a:r>
           </a:p>
         </p:txBody>
@@ -4703,7 +4294,7 @@
 </p:sld>
 </file>
 
-<file path=ppt/slides/slide11.xml><?xml version="1.0" encoding="utf-8"?>
+<file path=ppt/slides/slide3.xml><?xml version="1.0" encoding="utf-8"?>
 <p:sld xmlns:a="http://schemas.openxmlformats.org/drawingml/2006/main" xmlns:p="http://schemas.openxmlformats.org/presentationml/2006/main" xmlns:r="http://schemas.openxmlformats.org/officeDocument/2006/relationships">
   <p:cSld>
     <p:spTree>
@@ -4787,7 +4378,7 @@
                 <a:latin typeface="Microsoft YaHei"/>
                 <a:ea typeface="Microsoft YaHei"/>
               </a:rPr>
-              <a:t>结论与下一步</a:t>
+              <a:t>真实数据与简单基线</a:t>
             </a:r>
           </a:p>
         </p:txBody>
@@ -4860,69 +4451,69 @@
           <a:p>
             <a:pPr>
               <a:spcAft>
-                <a:spcPts val="1000"/>
+                <a:spcPts val="1200"/>
               </a:spcAft>
             </a:pPr>
             <a:r>
-              <a:rPr sz="2000" b="1">
+              <a:rPr sz="1900" b="1">
                 <a:solidFill>
                   <a:srgbClr val="1F3A5F"/>
                 </a:solidFill>
                 <a:latin typeface="Microsoft YaHei"/>
                 <a:ea typeface="Microsoft YaHei"/>
               </a:rPr>
-              <a:t>•  结论：CNN 显著优于多数类基线，大幅减少人工复核量</a:t>
+              <a:t>•  数据：Kaggle Surface Crack Detection，Positive/Negative 各 20000 张</a:t>
             </a:r>
           </a:p>
           <a:p>
             <a:pPr>
               <a:spcAft>
-                <a:spcPts val="1000"/>
+                <a:spcPts val="1200"/>
               </a:spcAft>
             </a:pPr>
             <a:r>
-              <a:rPr sz="2000" b="0">
+              <a:rPr sz="1900" b="0">
                 <a:solidFill>
                   <a:srgbClr val="1F3A5F"/>
                 </a:solidFill>
                 <a:latin typeface="Microsoft YaHei"/>
                 <a:ea typeface="Microsoft YaHei"/>
               </a:rPr>
-              <a:t>•  下一步：查看漏检图像共性（亮度 / 裂缝粗细 / 对比度）</a:t>
+              <a:t>•  检查：python train.py --check-data → PASSED</a:t>
             </a:r>
           </a:p>
           <a:p>
             <a:pPr>
               <a:spcAft>
-                <a:spcPts val="1000"/>
+                <a:spcPts val="1200"/>
               </a:spcAft>
             </a:pPr>
             <a:r>
-              <a:rPr sz="2000" b="0">
+              <a:rPr sz="1900" b="0">
                 <a:solidFill>
                   <a:srgbClr val="1F3A5F"/>
                 </a:solidFill>
                 <a:latin typeface="Microsoft YaHei"/>
                 <a:ea typeface="Microsoft YaHei"/>
               </a:rPr>
-              <a:t>•  考虑针对性数据增强后再训练</a:t>
+              <a:t>•  基线：多数类——所有图判为裂缝，acc 0.50，误报 150</a:t>
             </a:r>
           </a:p>
           <a:p>
             <a:pPr>
               <a:spcAft>
-                <a:spcPts val="1000"/>
+                <a:spcPts val="1200"/>
               </a:spcAft>
             </a:pPr>
             <a:r>
-              <a:rPr sz="2200" b="1">
+              <a:rPr sz="1900" b="1">
                 <a:solidFill>
                   <a:srgbClr val="1F3A5F"/>
                 </a:solidFill>
                 <a:latin typeface="Microsoft YaHei"/>
                 <a:ea typeface="Microsoft YaHei"/>
               </a:rPr>
-              <a:t>•  谢谢！</a:t>
+              <a:t>•  结论：基线几乎不可用，必须学习特征</a:t>
             </a:r>
           </a:p>
         </p:txBody>
@@ -4958,7 +4549,7 @@
                 <a:latin typeface="Microsoft YaHei"/>
                 <a:ea typeface="Microsoft YaHei"/>
               </a:rPr>
-              <a:t>11</a:t>
+              <a:t>03</a:t>
             </a:r>
           </a:p>
         </p:txBody>
@@ -4971,7 +4562,7 @@
 </p:sld>
 </file>
 
-<file path=ppt/slides/slide2.xml><?xml version="1.0" encoding="utf-8"?>
+<file path=ppt/slides/slide4.xml><?xml version="1.0" encoding="utf-8"?>
 <p:sld xmlns:a="http://schemas.openxmlformats.org/drawingml/2006/main" xmlns:p="http://schemas.openxmlformats.org/presentationml/2006/main" xmlns:r="http://schemas.openxmlformats.org/officeDocument/2006/relationships">
   <p:cSld>
     <p:spTree>
@@ -5055,7 +4646,7 @@
                 <a:latin typeface="Microsoft YaHei"/>
                 <a:ea typeface="Microsoft YaHei"/>
               </a:rPr>
-              <a:t>问题与使用者</a:t>
+              <a:t>候选方法与结果</a:t>
             </a:r>
           </a:p>
         </p:txBody>
@@ -5128,7 +4719,41 @@
           <a:p>
             <a:pPr>
               <a:spcAft>
-                <a:spcPts val="1000"/>
+                <a:spcPts val="1200"/>
+              </a:spcAft>
+            </a:pPr>
+            <a:r>
+              <a:rPr sz="1900" b="1">
+                <a:solidFill>
+                  <a:srgbClr val="1F3A5F"/>
+                </a:solidFill>
+                <a:latin typeface="Microsoft YaHei"/>
+                <a:ea typeface="Microsoft YaHei"/>
+              </a:rPr>
+              <a:t>•  候选：SmallCNN（2 卷积 + 2 池化 + 线性）</a:t>
+            </a:r>
+          </a:p>
+          <a:p>
+            <a:pPr>
+              <a:spcAft>
+                <a:spcPts val="1200"/>
+              </a:spcAft>
+            </a:pPr>
+            <a:r>
+              <a:rPr sz="1900" b="0">
+                <a:solidFill>
+                  <a:srgbClr val="1F3A5F"/>
+                </a:solidFill>
+                <a:latin typeface="Microsoft YaHei"/>
+                <a:ea typeface="Microsoft YaHei"/>
+              </a:rPr>
+              <a:t>•  训练：600/类、75/25、seed 2026、8 epochs（900/300）</a:t>
+            </a:r>
+          </a:p>
+          <a:p>
+            <a:pPr>
+              <a:spcAft>
+                <a:spcPts val="1200"/>
               </a:spcAft>
             </a:pPr>
             <a:r>
@@ -5139,30 +4764,13 @@
                 <a:latin typeface="Microsoft YaHei"/>
                 <a:ea typeface="Microsoft YaHei"/>
               </a:rPr>
-              <a:t>•  使用者：设施维护团队</a:t>
+              <a:t>•  对比：基线 acc 0.50 ｜ CNN acc 0.943</a:t>
             </a:r>
           </a:p>
           <a:p>
             <a:pPr>
               <a:spcAft>
-                <a:spcPts val="1000"/>
-              </a:spcAft>
-            </a:pPr>
-            <a:r>
-              <a:rPr sz="2000" b="1">
-                <a:solidFill>
-                  <a:srgbClr val="1F3A5F"/>
-                </a:solidFill>
-                <a:latin typeface="Microsoft YaHei"/>
-                <a:ea typeface="Microsoft YaHei"/>
-              </a:rPr>
-              <a:t>•  真实输入：混凝土表面照片</a:t>
-            </a:r>
-          </a:p>
-          <a:p>
-            <a:pPr>
-              <a:spcAft>
-                <a:spcPts val="1000"/>
+                <a:spcPts val="1200"/>
               </a:spcAft>
             </a:pPr>
             <a:r>
@@ -5173,41 +4781,7 @@
                 <a:latin typeface="Microsoft YaHei"/>
                 <a:ea typeface="Microsoft YaHei"/>
               </a:rPr>
-              <a:t>•  需要的输出：疑似裂缝 / 无裂缝，用于安排人工复核的顺序</a:t>
-            </a:r>
-          </a:p>
-          <a:p>
-            <a:pPr>
-              <a:spcAft>
-                <a:spcPts val="1000"/>
-              </a:spcAft>
-            </a:pPr>
-            <a:r>
-              <a:rPr sz="2000" b="0">
-                <a:solidFill>
-                  <a:srgbClr val="1F3A5F"/>
-                </a:solidFill>
-                <a:latin typeface="Microsoft YaHei"/>
-                <a:ea typeface="Microsoft YaHei"/>
-              </a:rPr>
-              <a:t>•  产品边界：只用于复核排序，不替代现场检查、工程师判断或安全决策</a:t>
-            </a:r>
-          </a:p>
-          <a:p>
-            <a:pPr>
-              <a:spcAft>
-                <a:spcPts val="1000"/>
-              </a:spcAft>
-            </a:pPr>
-            <a:r>
-              <a:rPr sz="2000" b="1">
-                <a:solidFill>
-                  <a:srgbClr val="1F3A5F"/>
-                </a:solidFill>
-                <a:latin typeface="Microsoft YaHei"/>
-                <a:ea typeface="Microsoft YaHei"/>
-              </a:rPr>
-              <a:t>•  最危险的错误：漏检裂缝（真实裂缝被标成无裂缝，不会被送去复核）</a:t>
+              <a:t>•  CNN：漏检 14 ｜ 误报 3；train_loss 0.68 → 0.20</a:t>
             </a:r>
           </a:p>
         </p:txBody>
@@ -5243,7 +4817,7 @@
                 <a:latin typeface="Microsoft YaHei"/>
                 <a:ea typeface="Microsoft YaHei"/>
               </a:rPr>
-              <a:t>02</a:t>
+              <a:t>04</a:t>
             </a:r>
           </a:p>
         </p:txBody>
@@ -5256,7 +4830,7 @@
 </p:sld>
 </file>
 
-<file path=ppt/slides/slide3.xml><?xml version="1.0" encoding="utf-8"?>
+<file path=ppt/slides/slide5.xml><?xml version="1.0" encoding="utf-8"?>
 <p:sld xmlns:a="http://schemas.openxmlformats.org/drawingml/2006/main" xmlns:p="http://schemas.openxmlformats.org/presentationml/2006/main" xmlns:r="http://schemas.openxmlformats.org/officeDocument/2006/relationships">
   <p:cSld>
     <p:spTree>
@@ -5340,7 +4914,7 @@
                 <a:latin typeface="Microsoft YaHei"/>
                 <a:ea typeface="Microsoft YaHei"/>
               </a:rPr>
-              <a:t>真实数据与检查</a:t>
+              <a:t>失败、限制与结论</a:t>
             </a:r>
           </a:p>
         </p:txBody>
@@ -5413,7 +4987,41 @@
           <a:p>
             <a:pPr>
               <a:spcAft>
-                <a:spcPts val="1000"/>
+                <a:spcPts val="1200"/>
+              </a:spcAft>
+            </a:pPr>
+            <a:r>
+              <a:rPr sz="1900" b="1">
+                <a:solidFill>
+                  <a:srgbClr val="1F3A5F"/>
+                </a:solidFill>
+                <a:latin typeface="Microsoft YaHei"/>
+                <a:ea typeface="Microsoft YaHei"/>
+              </a:rPr>
+              <a:t>•  失败：CNN 仍漏检 14 张裂缝（如 04283.jpg，2ep 与 8ep 均漏检）</a:t>
+            </a:r>
+          </a:p>
+          <a:p>
+            <a:pPr>
+              <a:spcAft>
+                <a:spcPts val="1200"/>
+              </a:spcAft>
+            </a:pPr>
+            <a:r>
+              <a:rPr sz="1900" b="0">
+                <a:solidFill>
+                  <a:srgbClr val="1F3A5F"/>
+                </a:solidFill>
+                <a:latin typeface="Microsoft YaHei"/>
+                <a:ea typeface="Microsoft YaHei"/>
+              </a:rPr>
+              <a:t>•  限制：不能替代现场检查 / 工程判断；切块数据有泄漏，数字偏乐观</a:t>
+            </a:r>
+          </a:p>
+          <a:p>
+            <a:pPr>
+              <a:spcAft>
+                <a:spcPts val="1200"/>
               </a:spcAft>
             </a:pPr>
             <a:r>
@@ -5424,75 +5032,24 @@
                 <a:latin typeface="Microsoft YaHei"/>
                 <a:ea typeface="Microsoft YaHei"/>
               </a:rPr>
-              <a:t>•  来源：Kaggle Surface Crack Detection</a:t>
+              <a:t>•  结论：CNN 显著优于基线，大幅减少人工复核量</a:t>
             </a:r>
           </a:p>
           <a:p>
             <a:pPr>
               <a:spcAft>
-                <a:spcPts val="1000"/>
+                <a:spcPts val="1200"/>
               </a:spcAft>
             </a:pPr>
             <a:r>
-              <a:rPr sz="2000" b="0">
+              <a:rPr sz="1900" b="0">
                 <a:solidFill>
                   <a:srgbClr val="1F3A5F"/>
                 </a:solidFill>
                 <a:latin typeface="Microsoft YaHei"/>
                 <a:ea typeface="Microsoft YaHei"/>
               </a:rPr>
-              <a:t>•  Positive / Negative 各 20000 张，227×227 RGB</a:t>
-            </a:r>
-          </a:p>
-          <a:p>
-            <a:pPr>
-              <a:spcAft>
-                <a:spcPts val="1000"/>
-              </a:spcAft>
-            </a:pPr>
-            <a:r>
-              <a:rPr sz="2000" b="0">
-                <a:solidFill>
-                  <a:srgbClr val="1F3A5F"/>
-                </a:solidFill>
-                <a:latin typeface="Microsoft YaHei"/>
-                <a:ea typeface="Microsoft YaHei"/>
-              </a:rPr>
-              <a:t>•  检查命令：python train.py --check-data</a:t>
-            </a:r>
-          </a:p>
-          <a:p>
-            <a:pPr>
-              <a:spcAft>
-                <a:spcPts val="1000"/>
-              </a:spcAft>
-            </a:pPr>
-            <a:r>
-              <a:rPr sz="2000" b="0">
-                <a:solidFill>
-                  <a:srgbClr val="1F3A5F"/>
-                </a:solidFill>
-                <a:latin typeface="Microsoft YaHei"/>
-                <a:ea typeface="Microsoft YaHei"/>
-              </a:rPr>
-              <a:t>•  结果：REAL DATA CHECK PASSED（两文件夹各 20000）</a:t>
-            </a:r>
-          </a:p>
-          <a:p>
-            <a:pPr>
-              <a:spcAft>
-                <a:spcPts val="1000"/>
-              </a:spcAft>
-            </a:pPr>
-            <a:r>
-              <a:rPr sz="2000" b="1">
-                <a:solidFill>
-                  <a:srgbClr val="1F3A5F"/>
-                </a:solidFill>
-                <a:latin typeface="Microsoft YaHei"/>
-                <a:ea typeface="Microsoft YaHei"/>
-              </a:rPr>
-              <a:t>•  风险：由 458 张高分辨率图切块生成，随机拆分存在数据泄漏</a:t>
+              <a:t>•  下一步：看漏检图像共性，再考虑数据增强</a:t>
             </a:r>
           </a:p>
         </p:txBody>
@@ -5528,1598 +5085,7 @@
                 <a:latin typeface="Microsoft YaHei"/>
                 <a:ea typeface="Microsoft YaHei"/>
               </a:rPr>
-              <a:t>03</a:t>
-            </a:r>
-          </a:p>
-        </p:txBody>
-      </p:sp>
-    </p:spTree>
-  </p:cSld>
-  <p:clrMapOvr>
-    <a:masterClrMapping/>
-  </p:clrMapOvr>
-</p:sld>
-</file>
-
-<file path=ppt/slides/slide4.xml><?xml version="1.0" encoding="utf-8"?>
-<p:sld xmlns:a="http://schemas.openxmlformats.org/drawingml/2006/main" xmlns:p="http://schemas.openxmlformats.org/presentationml/2006/main" xmlns:r="http://schemas.openxmlformats.org/officeDocument/2006/relationships">
-  <p:cSld>
-    <p:spTree>
-      <p:nvGrpSpPr>
-        <p:cNvPr id="1" name=""/>
-        <p:cNvGrpSpPr/>
-        <p:nvPr/>
-      </p:nvGrpSpPr>
-      <p:grpSpPr/>
-      <p:sp>
-        <p:nvSpPr>
-          <p:cNvPr id="2" name="Rectangle 1"/>
-          <p:cNvSpPr/>
-          <p:nvPr/>
-        </p:nvSpPr>
-        <p:spPr>
-          <a:xfrm>
-            <a:off x="0" y="0"/>
-            <a:ext cx="12191695" cy="1051560"/>
-          </a:xfrm>
-          <a:prstGeom prst="rect">
-            <a:avLst/>
-          </a:prstGeom>
-          <a:solidFill>
-            <a:srgbClr val="1F3A5F"/>
-          </a:solidFill>
-          <a:ln>
-            <a:noFill/>
-          </a:ln>
-          <a:effectLst/>
-        </p:spPr>
-        <p:style>
-          <a:lnRef idx="1">
-            <a:schemeClr val="accent1"/>
-          </a:lnRef>
-          <a:fillRef idx="3">
-            <a:schemeClr val="accent1"/>
-          </a:fillRef>
-          <a:effectRef idx="2">
-            <a:schemeClr val="accent1"/>
-          </a:effectRef>
-          <a:fontRef idx="minor">
-            <a:schemeClr val="lt1"/>
-          </a:fontRef>
-        </p:style>
-        <p:txBody>
-          <a:bodyPr rtlCol="0" anchor="ctr"/>
-          <a:lstStyle/>
-          <a:p>
-            <a:pPr algn="ctr"/>
-          </a:p>
-        </p:txBody>
-      </p:sp>
-      <p:sp>
-        <p:nvSpPr>
-          <p:cNvPr id="3" name="TextBox 2"/>
-          <p:cNvSpPr txBox="1"/>
-          <p:nvPr/>
-        </p:nvSpPr>
-        <p:spPr>
-          <a:xfrm>
-            <a:off x="640080" y="228600"/>
-            <a:ext cx="10515600" cy="640080"/>
-          </a:xfrm>
-          <a:prstGeom prst="rect">
-            <a:avLst/>
-          </a:prstGeom>
-          <a:noFill/>
-        </p:spPr>
-        <p:txBody>
-          <a:bodyPr wrap="square">
-            <a:spAutoFit/>
-          </a:bodyPr>
-          <a:lstStyle/>
-          <a:p>
-            <a:r>
-              <a:rPr sz="3000" b="1">
-                <a:solidFill>
-                  <a:srgbClr val="FFFFFF"/>
-                </a:solidFill>
-                <a:latin typeface="Microsoft YaHei"/>
-                <a:ea typeface="Microsoft YaHei"/>
-              </a:rPr>
-              <a:t>简单基线：多数类</a:t>
-            </a:r>
-          </a:p>
-        </p:txBody>
-      </p:sp>
-      <p:sp>
-        <p:nvSpPr>
-          <p:cNvPr id="4" name="Rectangle 3"/>
-          <p:cNvSpPr/>
-          <p:nvPr/>
-        </p:nvSpPr>
-        <p:spPr>
-          <a:xfrm>
-            <a:off x="0" y="1051560"/>
-            <a:ext cx="164592" cy="4892040"/>
-          </a:xfrm>
-          <a:prstGeom prst="rect">
-            <a:avLst/>
-          </a:prstGeom>
-          <a:solidFill>
-            <a:srgbClr val="E86A17"/>
-          </a:solidFill>
-          <a:ln>
-            <a:noFill/>
-          </a:ln>
-          <a:effectLst/>
-        </p:spPr>
-        <p:style>
-          <a:lnRef idx="1">
-            <a:schemeClr val="accent1"/>
-          </a:lnRef>
-          <a:fillRef idx="3">
-            <a:schemeClr val="accent1"/>
-          </a:fillRef>
-          <a:effectRef idx="2">
-            <a:schemeClr val="accent1"/>
-          </a:effectRef>
-          <a:fontRef idx="minor">
-            <a:schemeClr val="lt1"/>
-          </a:fontRef>
-        </p:style>
-        <p:txBody>
-          <a:bodyPr rtlCol="0" anchor="ctr"/>
-          <a:lstStyle/>
-          <a:p>
-            <a:pPr algn="ctr"/>
-          </a:p>
-        </p:txBody>
-      </p:sp>
-      <p:sp>
-        <p:nvSpPr>
-          <p:cNvPr id="5" name="TextBox 4"/>
-          <p:cNvSpPr txBox="1"/>
-          <p:nvPr/>
-        </p:nvSpPr>
-        <p:spPr>
-          <a:xfrm>
-            <a:off x="914400" y="1463040"/>
-            <a:ext cx="10424160" cy="4572000"/>
-          </a:xfrm>
-          <a:prstGeom prst="rect">
-            <a:avLst/>
-          </a:prstGeom>
-          <a:noFill/>
-        </p:spPr>
-        <p:txBody>
-          <a:bodyPr wrap="square">
-            <a:spAutoFit/>
-          </a:bodyPr>
-          <a:lstStyle/>
-          <a:p>
-            <a:pPr>
-              <a:spcAft>
-                <a:spcPts val="1000"/>
-              </a:spcAft>
-            </a:pPr>
-            <a:r>
-              <a:rPr sz="2000" b="1">
-                <a:solidFill>
-                  <a:srgbClr val="1F3A5F"/>
-                </a:solidFill>
-                <a:latin typeface="Microsoft YaHei"/>
-                <a:ea typeface="Microsoft YaHei"/>
-              </a:rPr>
-              <a:t>•  方法：把所有测试图都判为裂缝</a:t>
-            </a:r>
-          </a:p>
-          <a:p>
-            <a:pPr>
-              <a:spcAft>
-                <a:spcPts val="1000"/>
-              </a:spcAft>
-            </a:pPr>
-            <a:r>
-              <a:rPr sz="2000" b="0">
-                <a:solidFill>
-                  <a:srgbClr val="1F3A5F"/>
-                </a:solidFill>
-                <a:latin typeface="Microsoft YaHei"/>
-                <a:ea typeface="Microsoft YaHei"/>
-              </a:rPr>
-              <a:t>•  accuracy 0.50，crack_recall 1.0</a:t>
-            </a:r>
-          </a:p>
-          <a:p>
-            <a:pPr>
-              <a:spcAft>
-                <a:spcPts val="1000"/>
-              </a:spcAft>
-            </a:pPr>
-            <a:r>
-              <a:rPr sz="2000" b="0">
-                <a:solidFill>
-                  <a:srgbClr val="1F3A5F"/>
-                </a:solidFill>
-                <a:latin typeface="Microsoft YaHei"/>
-                <a:ea typeface="Microsoft YaHei"/>
-              </a:rPr>
-              <a:t>•  误报 150 / 300（全部无裂缝图都被标成裂缝）</a:t>
-            </a:r>
-          </a:p>
-          <a:p>
-            <a:pPr>
-              <a:spcAft>
-                <a:spcPts val="1000"/>
-              </a:spcAft>
-            </a:pPr>
-            <a:r>
-              <a:rPr sz="2000" b="1">
-                <a:solidFill>
-                  <a:srgbClr val="1F3A5F"/>
-                </a:solidFill>
-                <a:latin typeface="Microsoft YaHei"/>
-                <a:ea typeface="Microsoft YaHei"/>
-              </a:rPr>
-              <a:t>•  结论：作为筛查器几乎不可用，是改进的起点</a:t>
-            </a:r>
-          </a:p>
-        </p:txBody>
-      </p:sp>
-      <p:sp>
-        <p:nvSpPr>
-          <p:cNvPr id="6" name="TextBox 5"/>
-          <p:cNvSpPr txBox="1"/>
-          <p:nvPr/>
-        </p:nvSpPr>
-        <p:spPr>
-          <a:xfrm>
-            <a:off x="11155680" y="6446520"/>
-            <a:ext cx="914400" cy="365760"/>
-          </a:xfrm>
-          <a:prstGeom prst="rect">
-            <a:avLst/>
-          </a:prstGeom>
-          <a:noFill/>
-        </p:spPr>
-        <p:txBody>
-          <a:bodyPr wrap="square">
-            <a:spAutoFit/>
-          </a:bodyPr>
-          <a:lstStyle/>
-          <a:p>
-            <a:pPr algn="r"/>
-            <a:r>
-              <a:rPr sz="1200" b="0">
-                <a:solidFill>
-                  <a:srgbClr val="4A4A4A"/>
-                </a:solidFill>
-                <a:latin typeface="Microsoft YaHei"/>
-                <a:ea typeface="Microsoft YaHei"/>
-              </a:rPr>
-              <a:t>04</a:t>
-            </a:r>
-          </a:p>
-        </p:txBody>
-      </p:sp>
-    </p:spTree>
-  </p:cSld>
-  <p:clrMapOvr>
-    <a:masterClrMapping/>
-  </p:clrMapOvr>
-</p:sld>
-</file>
-
-<file path=ppt/slides/slide5.xml><?xml version="1.0" encoding="utf-8"?>
-<p:sld xmlns:a="http://schemas.openxmlformats.org/drawingml/2006/main" xmlns:p="http://schemas.openxmlformats.org/presentationml/2006/main" xmlns:r="http://schemas.openxmlformats.org/officeDocument/2006/relationships">
-  <p:cSld>
-    <p:spTree>
-      <p:nvGrpSpPr>
-        <p:cNvPr id="1" name=""/>
-        <p:cNvGrpSpPr/>
-        <p:nvPr/>
-      </p:nvGrpSpPr>
-      <p:grpSpPr/>
-      <p:sp>
-        <p:nvSpPr>
-          <p:cNvPr id="2" name="Rectangle 1"/>
-          <p:cNvSpPr/>
-          <p:nvPr/>
-        </p:nvSpPr>
-        <p:spPr>
-          <a:xfrm>
-            <a:off x="0" y="0"/>
-            <a:ext cx="12191695" cy="1051560"/>
-          </a:xfrm>
-          <a:prstGeom prst="rect">
-            <a:avLst/>
-          </a:prstGeom>
-          <a:solidFill>
-            <a:srgbClr val="1F3A5F"/>
-          </a:solidFill>
-          <a:ln>
-            <a:noFill/>
-          </a:ln>
-          <a:effectLst/>
-        </p:spPr>
-        <p:style>
-          <a:lnRef idx="1">
-            <a:schemeClr val="accent1"/>
-          </a:lnRef>
-          <a:fillRef idx="3">
-            <a:schemeClr val="accent1"/>
-          </a:fillRef>
-          <a:effectRef idx="2">
-            <a:schemeClr val="accent1"/>
-          </a:effectRef>
-          <a:fontRef idx="minor">
-            <a:schemeClr val="lt1"/>
-          </a:fontRef>
-        </p:style>
-        <p:txBody>
-          <a:bodyPr rtlCol="0" anchor="ctr"/>
-          <a:lstStyle/>
-          <a:p>
-            <a:pPr algn="ctr"/>
-          </a:p>
-        </p:txBody>
-      </p:sp>
-      <p:sp>
-        <p:nvSpPr>
-          <p:cNvPr id="3" name="TextBox 2"/>
-          <p:cNvSpPr txBox="1"/>
-          <p:nvPr/>
-        </p:nvSpPr>
-        <p:spPr>
-          <a:xfrm>
-            <a:off x="640080" y="228600"/>
-            <a:ext cx="10515600" cy="640080"/>
-          </a:xfrm>
-          <a:prstGeom prst="rect">
-            <a:avLst/>
-          </a:prstGeom>
-          <a:noFill/>
-        </p:spPr>
-        <p:txBody>
-          <a:bodyPr wrap="square">
-            <a:spAutoFit/>
-          </a:bodyPr>
-          <a:lstStyle/>
-          <a:p>
-            <a:r>
-              <a:rPr sz="3000" b="1">
-                <a:solidFill>
-                  <a:srgbClr val="FFFFFF"/>
-                </a:solidFill>
-                <a:latin typeface="Microsoft YaHei"/>
-                <a:ea typeface="Microsoft YaHei"/>
-              </a:rPr>
-              <a:t>候选方法：SmallCNN</a:t>
-            </a:r>
-          </a:p>
-        </p:txBody>
-      </p:sp>
-      <p:sp>
-        <p:nvSpPr>
-          <p:cNvPr id="4" name="Rectangle 3"/>
-          <p:cNvSpPr/>
-          <p:nvPr/>
-        </p:nvSpPr>
-        <p:spPr>
-          <a:xfrm>
-            <a:off x="0" y="1051560"/>
-            <a:ext cx="164592" cy="4892040"/>
-          </a:xfrm>
-          <a:prstGeom prst="rect">
-            <a:avLst/>
-          </a:prstGeom>
-          <a:solidFill>
-            <a:srgbClr val="E86A17"/>
-          </a:solidFill>
-          <a:ln>
-            <a:noFill/>
-          </a:ln>
-          <a:effectLst/>
-        </p:spPr>
-        <p:style>
-          <a:lnRef idx="1">
-            <a:schemeClr val="accent1"/>
-          </a:lnRef>
-          <a:fillRef idx="3">
-            <a:schemeClr val="accent1"/>
-          </a:fillRef>
-          <a:effectRef idx="2">
-            <a:schemeClr val="accent1"/>
-          </a:effectRef>
-          <a:fontRef idx="minor">
-            <a:schemeClr val="lt1"/>
-          </a:fontRef>
-        </p:style>
-        <p:txBody>
-          <a:bodyPr rtlCol="0" anchor="ctr"/>
-          <a:lstStyle/>
-          <a:p>
-            <a:pPr algn="ctr"/>
-          </a:p>
-        </p:txBody>
-      </p:sp>
-      <p:sp>
-        <p:nvSpPr>
-          <p:cNvPr id="5" name="TextBox 4"/>
-          <p:cNvSpPr txBox="1"/>
-          <p:nvPr/>
-        </p:nvSpPr>
-        <p:spPr>
-          <a:xfrm>
-            <a:off x="914400" y="1463040"/>
-            <a:ext cx="10424160" cy="4572000"/>
-          </a:xfrm>
-          <a:prstGeom prst="rect">
-            <a:avLst/>
-          </a:prstGeom>
-          <a:noFill/>
-        </p:spPr>
-        <p:txBody>
-          <a:bodyPr wrap="square">
-            <a:spAutoFit/>
-          </a:bodyPr>
-          <a:lstStyle/>
-          <a:p>
-            <a:pPr>
-              <a:spcAft>
-                <a:spcPts val="1000"/>
-              </a:spcAft>
-            </a:pPr>
-            <a:r>
-              <a:rPr sz="1800" b="1">
-                <a:solidFill>
-                  <a:srgbClr val="1F3A5F"/>
-                </a:solidFill>
-                <a:latin typeface="Microsoft YaHei"/>
-                <a:ea typeface="Microsoft YaHei"/>
-              </a:rPr>
-              <a:t>•  结构：Conv(3→8) → ReLU → Pool → Conv(8→16) → ReLU → Pool → Flatten → Linear</a:t>
-            </a:r>
-          </a:p>
-          <a:p>
-            <a:pPr>
-              <a:spcAft>
-                <a:spcPts val="1000"/>
-              </a:spcAft>
-            </a:pPr>
-            <a:r>
-              <a:rPr sz="1800" b="0">
-                <a:solidFill>
-                  <a:srgbClr val="1F3A5F"/>
-                </a:solidFill>
-                <a:latin typeface="Microsoft YaHei"/>
-                <a:ea typeface="Microsoft YaHei"/>
-              </a:rPr>
-              <a:t>•  输入 64×64×3，输出 2 类（无裂缝 / 裂缝）</a:t>
-            </a:r>
-          </a:p>
-          <a:p>
-            <a:pPr>
-              <a:spcAft>
-                <a:spcPts val="1000"/>
-              </a:spcAft>
-            </a:pPr>
-            <a:r>
-              <a:rPr sz="1800" b="0">
-                <a:solidFill>
-                  <a:srgbClr val="1F3A5F"/>
-                </a:solidFill>
-                <a:latin typeface="Microsoft YaHei"/>
-                <a:ea typeface="Microsoft YaHei"/>
-              </a:rPr>
-              <a:t>•  只实现 models.py 中的 SmallCNN</a:t>
-            </a:r>
-          </a:p>
-          <a:p>
-            <a:pPr>
-              <a:spcAft>
-                <a:spcPts val="1000"/>
-              </a:spcAft>
-            </a:pPr>
-            <a:r>
-              <a:rPr sz="1800" b="1">
-                <a:solidFill>
-                  <a:srgbClr val="1F3A5F"/>
-                </a:solidFill>
-                <a:latin typeface="Microsoft YaHei"/>
-                <a:ea typeface="Microsoft YaHei"/>
-              </a:rPr>
-              <a:t>•  保持不变：数据、划分、指标与训练流程均未改动</a:t>
-            </a:r>
-          </a:p>
-        </p:txBody>
-      </p:sp>
-      <p:sp>
-        <p:nvSpPr>
-          <p:cNvPr id="6" name="TextBox 5"/>
-          <p:cNvSpPr txBox="1"/>
-          <p:nvPr/>
-        </p:nvSpPr>
-        <p:spPr>
-          <a:xfrm>
-            <a:off x="11155680" y="6446520"/>
-            <a:ext cx="914400" cy="365760"/>
-          </a:xfrm>
-          <a:prstGeom prst="rect">
-            <a:avLst/>
-          </a:prstGeom>
-          <a:noFill/>
-        </p:spPr>
-        <p:txBody>
-          <a:bodyPr wrap="square">
-            <a:spAutoFit/>
-          </a:bodyPr>
-          <a:lstStyle/>
-          <a:p>
-            <a:pPr algn="r"/>
-            <a:r>
-              <a:rPr sz="1200" b="0">
-                <a:solidFill>
-                  <a:srgbClr val="4A4A4A"/>
-                </a:solidFill>
-                <a:latin typeface="Microsoft YaHei"/>
-                <a:ea typeface="Microsoft YaHei"/>
-              </a:rPr>
               <a:t>05</a:t>
-            </a:r>
-          </a:p>
-        </p:txBody>
-      </p:sp>
-    </p:spTree>
-  </p:cSld>
-  <p:clrMapOvr>
-    <a:masterClrMapping/>
-  </p:clrMapOvr>
-</p:sld>
-</file>
-
-<file path=ppt/slides/slide6.xml><?xml version="1.0" encoding="utf-8"?>
-<p:sld xmlns:a="http://schemas.openxmlformats.org/drawingml/2006/main" xmlns:p="http://schemas.openxmlformats.org/presentationml/2006/main" xmlns:r="http://schemas.openxmlformats.org/officeDocument/2006/relationships">
-  <p:cSld>
-    <p:spTree>
-      <p:nvGrpSpPr>
-        <p:cNvPr id="1" name=""/>
-        <p:cNvGrpSpPr/>
-        <p:nvPr/>
-      </p:nvGrpSpPr>
-      <p:grpSpPr/>
-      <p:sp>
-        <p:nvSpPr>
-          <p:cNvPr id="2" name="Rectangle 1"/>
-          <p:cNvSpPr/>
-          <p:nvPr/>
-        </p:nvSpPr>
-        <p:spPr>
-          <a:xfrm>
-            <a:off x="0" y="0"/>
-            <a:ext cx="12191695" cy="1051560"/>
-          </a:xfrm>
-          <a:prstGeom prst="rect">
-            <a:avLst/>
-          </a:prstGeom>
-          <a:solidFill>
-            <a:srgbClr val="1F3A5F"/>
-          </a:solidFill>
-          <a:ln>
-            <a:noFill/>
-          </a:ln>
-          <a:effectLst/>
-        </p:spPr>
-        <p:style>
-          <a:lnRef idx="1">
-            <a:schemeClr val="accent1"/>
-          </a:lnRef>
-          <a:fillRef idx="3">
-            <a:schemeClr val="accent1"/>
-          </a:fillRef>
-          <a:effectRef idx="2">
-            <a:schemeClr val="accent1"/>
-          </a:effectRef>
-          <a:fontRef idx="minor">
-            <a:schemeClr val="lt1"/>
-          </a:fontRef>
-        </p:style>
-        <p:txBody>
-          <a:bodyPr rtlCol="0" anchor="ctr"/>
-          <a:lstStyle/>
-          <a:p>
-            <a:pPr algn="ctr"/>
-          </a:p>
-        </p:txBody>
-      </p:sp>
-      <p:sp>
-        <p:nvSpPr>
-          <p:cNvPr id="3" name="TextBox 2"/>
-          <p:cNvSpPr txBox="1"/>
-          <p:nvPr/>
-        </p:nvSpPr>
-        <p:spPr>
-          <a:xfrm>
-            <a:off x="640080" y="228600"/>
-            <a:ext cx="10515600" cy="640080"/>
-          </a:xfrm>
-          <a:prstGeom prst="rect">
-            <a:avLst/>
-          </a:prstGeom>
-          <a:noFill/>
-        </p:spPr>
-        <p:txBody>
-          <a:bodyPr wrap="square">
-            <a:spAutoFit/>
-          </a:bodyPr>
-          <a:lstStyle/>
-          <a:p>
-            <a:r>
-              <a:rPr sz="3000" b="1">
-                <a:solidFill>
-                  <a:srgbClr val="FFFFFF"/>
-                </a:solidFill>
-                <a:latin typeface="Microsoft YaHei"/>
-                <a:ea typeface="Microsoft YaHei"/>
-              </a:rPr>
-              <a:t>训练设置与不变条件</a:t>
-            </a:r>
-          </a:p>
-        </p:txBody>
-      </p:sp>
-      <p:sp>
-        <p:nvSpPr>
-          <p:cNvPr id="4" name="Rectangle 3"/>
-          <p:cNvSpPr/>
-          <p:nvPr/>
-        </p:nvSpPr>
-        <p:spPr>
-          <a:xfrm>
-            <a:off x="0" y="1051560"/>
-            <a:ext cx="164592" cy="4892040"/>
-          </a:xfrm>
-          <a:prstGeom prst="rect">
-            <a:avLst/>
-          </a:prstGeom>
-          <a:solidFill>
-            <a:srgbClr val="E86A17"/>
-          </a:solidFill>
-          <a:ln>
-            <a:noFill/>
-          </a:ln>
-          <a:effectLst/>
-        </p:spPr>
-        <p:style>
-          <a:lnRef idx="1">
-            <a:schemeClr val="accent1"/>
-          </a:lnRef>
-          <a:fillRef idx="3">
-            <a:schemeClr val="accent1"/>
-          </a:fillRef>
-          <a:effectRef idx="2">
-            <a:schemeClr val="accent1"/>
-          </a:effectRef>
-          <a:fontRef idx="minor">
-            <a:schemeClr val="lt1"/>
-          </a:fontRef>
-        </p:style>
-        <p:txBody>
-          <a:bodyPr rtlCol="0" anchor="ctr"/>
-          <a:lstStyle/>
-          <a:p>
-            <a:pPr algn="ctr"/>
-          </a:p>
-        </p:txBody>
-      </p:sp>
-      <p:sp>
-        <p:nvSpPr>
-          <p:cNvPr id="5" name="TextBox 4"/>
-          <p:cNvSpPr txBox="1"/>
-          <p:nvPr/>
-        </p:nvSpPr>
-        <p:spPr>
-          <a:xfrm>
-            <a:off x="914400" y="1463040"/>
-            <a:ext cx="10424160" cy="4572000"/>
-          </a:xfrm>
-          <a:prstGeom prst="rect">
-            <a:avLst/>
-          </a:prstGeom>
-          <a:noFill/>
-        </p:spPr>
-        <p:txBody>
-          <a:bodyPr wrap="square">
-            <a:spAutoFit/>
-          </a:bodyPr>
-          <a:lstStyle/>
-          <a:p>
-            <a:pPr>
-              <a:spcAft>
-                <a:spcPts val="1000"/>
-              </a:spcAft>
-            </a:pPr>
-            <a:r>
-              <a:rPr sz="2000" b="1">
-                <a:solidFill>
-                  <a:srgbClr val="1F3A5F"/>
-                </a:solidFill>
-                <a:latin typeface="Microsoft YaHei"/>
-                <a:ea typeface="Microsoft YaHei"/>
-              </a:rPr>
-              <a:t>•  划分：每类最多 600 张，75/25 拆分，seed=2026</a:t>
-            </a:r>
-          </a:p>
-          <a:p>
-            <a:pPr>
-              <a:spcAft>
-                <a:spcPts val="1000"/>
-              </a:spcAft>
-            </a:pPr>
-            <a:r>
-              <a:rPr sz="2000" b="0">
-                <a:solidFill>
-                  <a:srgbClr val="1F3A5F"/>
-                </a:solidFill>
-                <a:latin typeface="Microsoft YaHei"/>
-                <a:ea typeface="Microsoft YaHei"/>
-              </a:rPr>
-              <a:t>•  规模：900 训练 / 300 测试</a:t>
-            </a:r>
-          </a:p>
-          <a:p>
-            <a:pPr>
-              <a:spcAft>
-                <a:spcPts val="1000"/>
-              </a:spcAft>
-            </a:pPr>
-            <a:r>
-              <a:rPr sz="2000" b="0">
-                <a:solidFill>
-                  <a:srgbClr val="1F3A5F"/>
-                </a:solidFill>
-                <a:latin typeface="Microsoft YaHei"/>
-                <a:ea typeface="Microsoft YaHei"/>
-              </a:rPr>
-              <a:t>•  训练：8 epochs，Adam(lr=0.001)，CrossEntropy</a:t>
-            </a:r>
-          </a:p>
-          <a:p>
-            <a:pPr>
-              <a:spcAft>
-                <a:spcPts val="1000"/>
-              </a:spcAft>
-            </a:pPr>
-            <a:r>
-              <a:rPr sz="2000" b="0">
-                <a:solidFill>
-                  <a:srgbClr val="1F3A5F"/>
-                </a:solidFill>
-                <a:latin typeface="Microsoft YaHei"/>
-                <a:ea typeface="Microsoft YaHei"/>
-              </a:rPr>
-              <a:t>•  指标：accuracy / 漏检 FN / 误报 FP（同一条件下比较）</a:t>
-            </a:r>
-          </a:p>
-        </p:txBody>
-      </p:sp>
-      <p:sp>
-        <p:nvSpPr>
-          <p:cNvPr id="6" name="TextBox 5"/>
-          <p:cNvSpPr txBox="1"/>
-          <p:nvPr/>
-        </p:nvSpPr>
-        <p:spPr>
-          <a:xfrm>
-            <a:off x="11155680" y="6446520"/>
-            <a:ext cx="914400" cy="365760"/>
-          </a:xfrm>
-          <a:prstGeom prst="rect">
-            <a:avLst/>
-          </a:prstGeom>
-          <a:noFill/>
-        </p:spPr>
-        <p:txBody>
-          <a:bodyPr wrap="square">
-            <a:spAutoFit/>
-          </a:bodyPr>
-          <a:lstStyle/>
-          <a:p>
-            <a:pPr algn="r"/>
-            <a:r>
-              <a:rPr sz="1200" b="0">
-                <a:solidFill>
-                  <a:srgbClr val="4A4A4A"/>
-                </a:solidFill>
-                <a:latin typeface="Microsoft YaHei"/>
-                <a:ea typeface="Microsoft YaHei"/>
-              </a:rPr>
-              <a:t>06</a:t>
-            </a:r>
-          </a:p>
-        </p:txBody>
-      </p:sp>
-    </p:spTree>
-  </p:cSld>
-  <p:clrMapOvr>
-    <a:masterClrMapping/>
-  </p:clrMapOvr>
-</p:sld>
-</file>
-
-<file path=ppt/slides/slide7.xml><?xml version="1.0" encoding="utf-8"?>
-<p:sld xmlns:a="http://schemas.openxmlformats.org/drawingml/2006/main" xmlns:p="http://schemas.openxmlformats.org/presentationml/2006/main" xmlns:r="http://schemas.openxmlformats.org/officeDocument/2006/relationships">
-  <p:cSld>
-    <p:spTree>
-      <p:nvGrpSpPr>
-        <p:cNvPr id="1" name=""/>
-        <p:cNvGrpSpPr/>
-        <p:nvPr/>
-      </p:nvGrpSpPr>
-      <p:grpSpPr/>
-      <p:sp>
-        <p:nvSpPr>
-          <p:cNvPr id="2" name="Rectangle 1"/>
-          <p:cNvSpPr/>
-          <p:nvPr/>
-        </p:nvSpPr>
-        <p:spPr>
-          <a:xfrm>
-            <a:off x="0" y="0"/>
-            <a:ext cx="12191695" cy="1051560"/>
-          </a:xfrm>
-          <a:prstGeom prst="rect">
-            <a:avLst/>
-          </a:prstGeom>
-          <a:solidFill>
-            <a:srgbClr val="1F3A5F"/>
-          </a:solidFill>
-          <a:ln>
-            <a:noFill/>
-          </a:ln>
-          <a:effectLst/>
-        </p:spPr>
-        <p:style>
-          <a:lnRef idx="1">
-            <a:schemeClr val="accent1"/>
-          </a:lnRef>
-          <a:fillRef idx="3">
-            <a:schemeClr val="accent1"/>
-          </a:fillRef>
-          <a:effectRef idx="2">
-            <a:schemeClr val="accent1"/>
-          </a:effectRef>
-          <a:fontRef idx="minor">
-            <a:schemeClr val="lt1"/>
-          </a:fontRef>
-        </p:style>
-        <p:txBody>
-          <a:bodyPr rtlCol="0" anchor="ctr"/>
-          <a:lstStyle/>
-          <a:p>
-            <a:pPr algn="ctr"/>
-          </a:p>
-        </p:txBody>
-      </p:sp>
-      <p:sp>
-        <p:nvSpPr>
-          <p:cNvPr id="3" name="TextBox 2"/>
-          <p:cNvSpPr txBox="1"/>
-          <p:nvPr/>
-        </p:nvSpPr>
-        <p:spPr>
-          <a:xfrm>
-            <a:off x="640080" y="228600"/>
-            <a:ext cx="10515600" cy="640080"/>
-          </a:xfrm>
-          <a:prstGeom prst="rect">
-            <a:avLst/>
-          </a:prstGeom>
-          <a:noFill/>
-        </p:spPr>
-        <p:txBody>
-          <a:bodyPr wrap="square">
-            <a:spAutoFit/>
-          </a:bodyPr>
-          <a:lstStyle/>
-          <a:p>
-            <a:r>
-              <a:rPr sz="3000" b="1">
-                <a:solidFill>
-                  <a:srgbClr val="FFFFFF"/>
-                </a:solidFill>
-                <a:latin typeface="Microsoft YaHei"/>
-                <a:ea typeface="Microsoft YaHei"/>
-              </a:rPr>
-              <a:t>基线 vs CNN</a:t>
-            </a:r>
-          </a:p>
-        </p:txBody>
-      </p:sp>
-      <p:sp>
-        <p:nvSpPr>
-          <p:cNvPr id="4" name="Rectangle 3"/>
-          <p:cNvSpPr/>
-          <p:nvPr/>
-        </p:nvSpPr>
-        <p:spPr>
-          <a:xfrm>
-            <a:off x="0" y="1051560"/>
-            <a:ext cx="164592" cy="4892040"/>
-          </a:xfrm>
-          <a:prstGeom prst="rect">
-            <a:avLst/>
-          </a:prstGeom>
-          <a:solidFill>
-            <a:srgbClr val="E86A17"/>
-          </a:solidFill>
-          <a:ln>
-            <a:noFill/>
-          </a:ln>
-          <a:effectLst/>
-        </p:spPr>
-        <p:style>
-          <a:lnRef idx="1">
-            <a:schemeClr val="accent1"/>
-          </a:lnRef>
-          <a:fillRef idx="3">
-            <a:schemeClr val="accent1"/>
-          </a:fillRef>
-          <a:effectRef idx="2">
-            <a:schemeClr val="accent1"/>
-          </a:effectRef>
-          <a:fontRef idx="minor">
-            <a:schemeClr val="lt1"/>
-          </a:fontRef>
-        </p:style>
-        <p:txBody>
-          <a:bodyPr rtlCol="0" anchor="ctr"/>
-          <a:lstStyle/>
-          <a:p>
-            <a:pPr algn="ctr"/>
-          </a:p>
-        </p:txBody>
-      </p:sp>
-      <p:sp>
-        <p:nvSpPr>
-          <p:cNvPr id="5" name="TextBox 4"/>
-          <p:cNvSpPr txBox="1"/>
-          <p:nvPr/>
-        </p:nvSpPr>
-        <p:spPr>
-          <a:xfrm>
-            <a:off x="914400" y="1463040"/>
-            <a:ext cx="10424160" cy="4572000"/>
-          </a:xfrm>
-          <a:prstGeom prst="rect">
-            <a:avLst/>
-          </a:prstGeom>
-          <a:noFill/>
-        </p:spPr>
-        <p:txBody>
-          <a:bodyPr wrap="square">
-            <a:spAutoFit/>
-          </a:bodyPr>
-          <a:lstStyle/>
-          <a:p>
-            <a:pPr>
-              <a:spcAft>
-                <a:spcPts val="1000"/>
-              </a:spcAft>
-            </a:pPr>
-            <a:r>
-              <a:rPr sz="2200" b="1">
-                <a:solidFill>
-                  <a:srgbClr val="1F3A5F"/>
-                </a:solidFill>
-                <a:latin typeface="Microsoft YaHei"/>
-                <a:ea typeface="Microsoft YaHei"/>
-              </a:rPr>
-              <a:t>•  多数类基线：accuracy 0.50 ｜ 误报 150</a:t>
-            </a:r>
-          </a:p>
-          <a:p>
-            <a:pPr>
-              <a:spcAft>
-                <a:spcPts val="1000"/>
-              </a:spcAft>
-            </a:pPr>
-            <a:r>
-              <a:rPr sz="2200" b="1">
-                <a:solidFill>
-                  <a:srgbClr val="1F3A5F"/>
-                </a:solidFill>
-                <a:latin typeface="Microsoft YaHei"/>
-                <a:ea typeface="Microsoft YaHei"/>
-              </a:rPr>
-              <a:t>•  SmallCNN（8ep）：accuracy 0.943 ｜ 漏检 14 ｜ 误报 3</a:t>
-            </a:r>
-          </a:p>
-          <a:p>
-            <a:pPr>
-              <a:spcAft>
-                <a:spcPts val="1000"/>
-              </a:spcAft>
-            </a:pPr>
-            <a:r>
-              <a:rPr sz="2000" b="0">
-                <a:solidFill>
-                  <a:srgbClr val="1F3A5F"/>
-                </a:solidFill>
-                <a:latin typeface="Microsoft YaHei"/>
-                <a:ea typeface="Microsoft YaHei"/>
-              </a:rPr>
-              <a:t>•  误报大幅下降，漏检明显减少，筛查器可用</a:t>
-            </a:r>
-          </a:p>
-        </p:txBody>
-      </p:sp>
-      <p:sp>
-        <p:nvSpPr>
-          <p:cNvPr id="6" name="TextBox 5"/>
-          <p:cNvSpPr txBox="1"/>
-          <p:nvPr/>
-        </p:nvSpPr>
-        <p:spPr>
-          <a:xfrm>
-            <a:off x="11155680" y="6446520"/>
-            <a:ext cx="914400" cy="365760"/>
-          </a:xfrm>
-          <a:prstGeom prst="rect">
-            <a:avLst/>
-          </a:prstGeom>
-          <a:noFill/>
-        </p:spPr>
-        <p:txBody>
-          <a:bodyPr wrap="square">
-            <a:spAutoFit/>
-          </a:bodyPr>
-          <a:lstStyle/>
-          <a:p>
-            <a:pPr algn="r"/>
-            <a:r>
-              <a:rPr sz="1200" b="0">
-                <a:solidFill>
-                  <a:srgbClr val="4A4A4A"/>
-                </a:solidFill>
-                <a:latin typeface="Microsoft YaHei"/>
-                <a:ea typeface="Microsoft YaHei"/>
-              </a:rPr>
-              <a:t>07</a:t>
-            </a:r>
-          </a:p>
-        </p:txBody>
-      </p:sp>
-    </p:spTree>
-  </p:cSld>
-  <p:clrMapOvr>
-    <a:masterClrMapping/>
-  </p:clrMapOvr>
-</p:sld>
-</file>
-
-<file path=ppt/slides/slide8.xml><?xml version="1.0" encoding="utf-8"?>
-<p:sld xmlns:a="http://schemas.openxmlformats.org/drawingml/2006/main" xmlns:p="http://schemas.openxmlformats.org/presentationml/2006/main" xmlns:r="http://schemas.openxmlformats.org/officeDocument/2006/relationships">
-  <p:cSld>
-    <p:spTree>
-      <p:nvGrpSpPr>
-        <p:cNvPr id="1" name=""/>
-        <p:cNvGrpSpPr/>
-        <p:nvPr/>
-      </p:nvGrpSpPr>
-      <p:grpSpPr/>
-      <p:sp>
-        <p:nvSpPr>
-          <p:cNvPr id="2" name="Rectangle 1"/>
-          <p:cNvSpPr/>
-          <p:nvPr/>
-        </p:nvSpPr>
-        <p:spPr>
-          <a:xfrm>
-            <a:off x="0" y="0"/>
-            <a:ext cx="12191695" cy="1051560"/>
-          </a:xfrm>
-          <a:prstGeom prst="rect">
-            <a:avLst/>
-          </a:prstGeom>
-          <a:solidFill>
-            <a:srgbClr val="1F3A5F"/>
-          </a:solidFill>
-          <a:ln>
-            <a:noFill/>
-          </a:ln>
-          <a:effectLst/>
-        </p:spPr>
-        <p:style>
-          <a:lnRef idx="1">
-            <a:schemeClr val="accent1"/>
-          </a:lnRef>
-          <a:fillRef idx="3">
-            <a:schemeClr val="accent1"/>
-          </a:fillRef>
-          <a:effectRef idx="2">
-            <a:schemeClr val="accent1"/>
-          </a:effectRef>
-          <a:fontRef idx="minor">
-            <a:schemeClr val="lt1"/>
-          </a:fontRef>
-        </p:style>
-        <p:txBody>
-          <a:bodyPr rtlCol="0" anchor="ctr"/>
-          <a:lstStyle/>
-          <a:p>
-            <a:pPr algn="ctr"/>
-          </a:p>
-        </p:txBody>
-      </p:sp>
-      <p:sp>
-        <p:nvSpPr>
-          <p:cNvPr id="3" name="TextBox 2"/>
-          <p:cNvSpPr txBox="1"/>
-          <p:nvPr/>
-        </p:nvSpPr>
-        <p:spPr>
-          <a:xfrm>
-            <a:off x="640080" y="228600"/>
-            <a:ext cx="10515600" cy="640080"/>
-          </a:xfrm>
-          <a:prstGeom prst="rect">
-            <a:avLst/>
-          </a:prstGeom>
-          <a:noFill/>
-        </p:spPr>
-        <p:txBody>
-          <a:bodyPr wrap="square">
-            <a:spAutoFit/>
-          </a:bodyPr>
-          <a:lstStyle/>
-          <a:p>
-            <a:r>
-              <a:rPr sz="3000" b="1">
-                <a:solidFill>
-                  <a:srgbClr val="FFFFFF"/>
-                </a:solidFill>
-                <a:latin typeface="Microsoft YaHei"/>
-                <a:ea typeface="Microsoft YaHei"/>
-              </a:rPr>
-              <a:t>一条最重要的证据</a:t>
-            </a:r>
-          </a:p>
-        </p:txBody>
-      </p:sp>
-      <p:sp>
-        <p:nvSpPr>
-          <p:cNvPr id="4" name="Rectangle 3"/>
-          <p:cNvSpPr/>
-          <p:nvPr/>
-        </p:nvSpPr>
-        <p:spPr>
-          <a:xfrm>
-            <a:off x="0" y="1051560"/>
-            <a:ext cx="164592" cy="4892040"/>
-          </a:xfrm>
-          <a:prstGeom prst="rect">
-            <a:avLst/>
-          </a:prstGeom>
-          <a:solidFill>
-            <a:srgbClr val="E86A17"/>
-          </a:solidFill>
-          <a:ln>
-            <a:noFill/>
-          </a:ln>
-          <a:effectLst/>
-        </p:spPr>
-        <p:style>
-          <a:lnRef idx="1">
-            <a:schemeClr val="accent1"/>
-          </a:lnRef>
-          <a:fillRef idx="3">
-            <a:schemeClr val="accent1"/>
-          </a:fillRef>
-          <a:effectRef idx="2">
-            <a:schemeClr val="accent1"/>
-          </a:effectRef>
-          <a:fontRef idx="minor">
-            <a:schemeClr val="lt1"/>
-          </a:fontRef>
-        </p:style>
-        <p:txBody>
-          <a:bodyPr rtlCol="0" anchor="ctr"/>
-          <a:lstStyle/>
-          <a:p>
-            <a:pPr algn="ctr"/>
-          </a:p>
-        </p:txBody>
-      </p:sp>
-      <p:sp>
-        <p:nvSpPr>
-          <p:cNvPr id="5" name="TextBox 4"/>
-          <p:cNvSpPr txBox="1"/>
-          <p:nvPr/>
-        </p:nvSpPr>
-        <p:spPr>
-          <a:xfrm>
-            <a:off x="914400" y="1463040"/>
-            <a:ext cx="10424160" cy="4572000"/>
-          </a:xfrm>
-          <a:prstGeom prst="rect">
-            <a:avLst/>
-          </a:prstGeom>
-          <a:noFill/>
-        </p:spPr>
-        <p:txBody>
-          <a:bodyPr wrap="square">
-            <a:spAutoFit/>
-          </a:bodyPr>
-          <a:lstStyle/>
-          <a:p>
-            <a:pPr>
-              <a:spcAft>
-                <a:spcPts val="1000"/>
-              </a:spcAft>
-            </a:pPr>
-            <a:r>
-              <a:rPr sz="2200" b="1">
-                <a:solidFill>
-                  <a:srgbClr val="1F3A5F"/>
-                </a:solidFill>
-                <a:latin typeface="Microsoft YaHei"/>
-                <a:ea typeface="Microsoft YaHei"/>
-              </a:rPr>
-              <a:t>•  CNN 8ep：accuracy 0.943</a:t>
-            </a:r>
-          </a:p>
-          <a:p>
-            <a:pPr>
-              <a:spcAft>
-                <a:spcPts val="1000"/>
-              </a:spcAft>
-            </a:pPr>
-            <a:r>
-              <a:rPr sz="2000" b="0">
-                <a:solidFill>
-                  <a:srgbClr val="1F3A5F"/>
-                </a:solidFill>
-                <a:latin typeface="Microsoft YaHei"/>
-                <a:ea typeface="Microsoft YaHei"/>
-              </a:rPr>
-              <a:t>•  漏检 14 ｜ 误报 3（基线误报 150）</a:t>
-            </a:r>
-          </a:p>
-          <a:p>
-            <a:pPr>
-              <a:spcAft>
-                <a:spcPts val="1000"/>
-              </a:spcAft>
-            </a:pPr>
-            <a:r>
-              <a:rPr sz="2000" b="0">
-                <a:solidFill>
-                  <a:srgbClr val="1F3A5F"/>
-                </a:solidFill>
-                <a:latin typeface="Microsoft YaHei"/>
-                <a:ea typeface="Microsoft YaHei"/>
-              </a:rPr>
-              <a:t>•  train_loss 0.68 → 0.20（明显收敛）</a:t>
-            </a:r>
-          </a:p>
-          <a:p>
-            <a:pPr>
-              <a:spcAft>
-                <a:spcPts val="1000"/>
-              </a:spcAft>
-            </a:pPr>
-            <a:r>
-              <a:rPr sz="1800" b="0">
-                <a:solidFill>
-                  <a:srgbClr val="1F3A5F"/>
-                </a:solidFill>
-                <a:latin typeface="Microsoft YaHei"/>
-                <a:ea typeface="Microsoft YaHei"/>
-              </a:rPr>
-              <a:t>•  900 训练 / 300 测试，可复现</a:t>
-            </a:r>
-          </a:p>
-        </p:txBody>
-      </p:sp>
-      <p:sp>
-        <p:nvSpPr>
-          <p:cNvPr id="6" name="TextBox 5"/>
-          <p:cNvSpPr txBox="1"/>
-          <p:nvPr/>
-        </p:nvSpPr>
-        <p:spPr>
-          <a:xfrm>
-            <a:off x="11155680" y="6446520"/>
-            <a:ext cx="914400" cy="365760"/>
-          </a:xfrm>
-          <a:prstGeom prst="rect">
-            <a:avLst/>
-          </a:prstGeom>
-          <a:noFill/>
-        </p:spPr>
-        <p:txBody>
-          <a:bodyPr wrap="square">
-            <a:spAutoFit/>
-          </a:bodyPr>
-          <a:lstStyle/>
-          <a:p>
-            <a:pPr algn="r"/>
-            <a:r>
-              <a:rPr sz="1200" b="0">
-                <a:solidFill>
-                  <a:srgbClr val="4A4A4A"/>
-                </a:solidFill>
-                <a:latin typeface="Microsoft YaHei"/>
-                <a:ea typeface="Microsoft YaHei"/>
-              </a:rPr>
-              <a:t>08</a:t>
-            </a:r>
-          </a:p>
-        </p:txBody>
-      </p:sp>
-    </p:spTree>
-  </p:cSld>
-  <p:clrMapOvr>
-    <a:masterClrMapping/>
-  </p:clrMapOvr>
-</p:sld>
-</file>
-
-<file path=ppt/slides/slide9.xml><?xml version="1.0" encoding="utf-8"?>
-<p:sld xmlns:a="http://schemas.openxmlformats.org/drawingml/2006/main" xmlns:p="http://schemas.openxmlformats.org/presentationml/2006/main" xmlns:r="http://schemas.openxmlformats.org/officeDocument/2006/relationships">
-  <p:cSld>
-    <p:spTree>
-      <p:nvGrpSpPr>
-        <p:cNvPr id="1" name=""/>
-        <p:cNvGrpSpPr/>
-        <p:nvPr/>
-      </p:nvGrpSpPr>
-      <p:grpSpPr/>
-      <p:sp>
-        <p:nvSpPr>
-          <p:cNvPr id="2" name="Rectangle 1"/>
-          <p:cNvSpPr/>
-          <p:nvPr/>
-        </p:nvSpPr>
-        <p:spPr>
-          <a:xfrm>
-            <a:off x="0" y="0"/>
-            <a:ext cx="12191695" cy="1051560"/>
-          </a:xfrm>
-          <a:prstGeom prst="rect">
-            <a:avLst/>
-          </a:prstGeom>
-          <a:solidFill>
-            <a:srgbClr val="1F3A5F"/>
-          </a:solidFill>
-          <a:ln>
-            <a:noFill/>
-          </a:ln>
-          <a:effectLst/>
-        </p:spPr>
-        <p:style>
-          <a:lnRef idx="1">
-            <a:schemeClr val="accent1"/>
-          </a:lnRef>
-          <a:fillRef idx="3">
-            <a:schemeClr val="accent1"/>
-          </a:fillRef>
-          <a:effectRef idx="2">
-            <a:schemeClr val="accent1"/>
-          </a:effectRef>
-          <a:fontRef idx="minor">
-            <a:schemeClr val="lt1"/>
-          </a:fontRef>
-        </p:style>
-        <p:txBody>
-          <a:bodyPr rtlCol="0" anchor="ctr"/>
-          <a:lstStyle/>
-          <a:p>
-            <a:pPr algn="ctr"/>
-          </a:p>
-        </p:txBody>
-      </p:sp>
-      <p:sp>
-        <p:nvSpPr>
-          <p:cNvPr id="3" name="TextBox 2"/>
-          <p:cNvSpPr txBox="1"/>
-          <p:nvPr/>
-        </p:nvSpPr>
-        <p:spPr>
-          <a:xfrm>
-            <a:off x="640080" y="228600"/>
-            <a:ext cx="10515600" cy="640080"/>
-          </a:xfrm>
-          <a:prstGeom prst="rect">
-            <a:avLst/>
-          </a:prstGeom>
-          <a:noFill/>
-        </p:spPr>
-        <p:txBody>
-          <a:bodyPr wrap="square">
-            <a:spAutoFit/>
-          </a:bodyPr>
-          <a:lstStyle/>
-          <a:p>
-            <a:r>
-              <a:rPr sz="3000" b="1">
-                <a:solidFill>
-                  <a:srgbClr val="FFFFFF"/>
-                </a:solidFill>
-                <a:latin typeface="Microsoft YaHei"/>
-                <a:ea typeface="Microsoft YaHei"/>
-              </a:rPr>
-              <a:t>真实案例：漏检裂缝</a:t>
-            </a:r>
-          </a:p>
-        </p:txBody>
-      </p:sp>
-      <p:sp>
-        <p:nvSpPr>
-          <p:cNvPr id="4" name="Rectangle 3"/>
-          <p:cNvSpPr/>
-          <p:nvPr/>
-        </p:nvSpPr>
-        <p:spPr>
-          <a:xfrm>
-            <a:off x="0" y="1051560"/>
-            <a:ext cx="164592" cy="4892040"/>
-          </a:xfrm>
-          <a:prstGeom prst="rect">
-            <a:avLst/>
-          </a:prstGeom>
-          <a:solidFill>
-            <a:srgbClr val="E86A17"/>
-          </a:solidFill>
-          <a:ln>
-            <a:noFill/>
-          </a:ln>
-          <a:effectLst/>
-        </p:spPr>
-        <p:style>
-          <a:lnRef idx="1">
-            <a:schemeClr val="accent1"/>
-          </a:lnRef>
-          <a:fillRef idx="3">
-            <a:schemeClr val="accent1"/>
-          </a:fillRef>
-          <a:effectRef idx="2">
-            <a:schemeClr val="accent1"/>
-          </a:effectRef>
-          <a:fontRef idx="minor">
-            <a:schemeClr val="lt1"/>
-          </a:fontRef>
-        </p:style>
-        <p:txBody>
-          <a:bodyPr rtlCol="0" anchor="ctr"/>
-          <a:lstStyle/>
-          <a:p>
-            <a:pPr algn="ctr"/>
-          </a:p>
-        </p:txBody>
-      </p:sp>
-      <p:sp>
-        <p:nvSpPr>
-          <p:cNvPr id="5" name="TextBox 4"/>
-          <p:cNvSpPr txBox="1"/>
-          <p:nvPr/>
-        </p:nvSpPr>
-        <p:spPr>
-          <a:xfrm>
-            <a:off x="914400" y="1463040"/>
-            <a:ext cx="10424160" cy="4572000"/>
-          </a:xfrm>
-          <a:prstGeom prst="rect">
-            <a:avLst/>
-          </a:prstGeom>
-          <a:noFill/>
-        </p:spPr>
-        <p:txBody>
-          <a:bodyPr wrap="square">
-            <a:spAutoFit/>
-          </a:bodyPr>
-          <a:lstStyle/>
-          <a:p>
-            <a:pPr>
-              <a:spcAft>
-                <a:spcPts val="1000"/>
-              </a:spcAft>
-            </a:pPr>
-            <a:r>
-              <a:rPr sz="2000" b="1">
-                <a:solidFill>
-                  <a:srgbClr val="1F3A5F"/>
-                </a:solidFill>
-                <a:latin typeface="Microsoft YaHei"/>
-                <a:ea typeface="Microsoft YaHei"/>
-              </a:rPr>
-              <a:t>•  样本：data/raw/Positive/04283.jpg</a:t>
-            </a:r>
-          </a:p>
-          <a:p>
-            <a:pPr>
-              <a:spcAft>
-                <a:spcPts val="1000"/>
-              </a:spcAft>
-            </a:pPr>
-            <a:r>
-              <a:rPr sz="2000" b="0">
-                <a:solidFill>
-                  <a:srgbClr val="1F3A5F"/>
-                </a:solidFill>
-                <a:latin typeface="Microsoft YaHei"/>
-                <a:ea typeface="Microsoft YaHei"/>
-              </a:rPr>
-              <a:t>•  真实结果：crack；系统输出：no_crack（漏检）</a:t>
-            </a:r>
-          </a:p>
-          <a:p>
-            <a:pPr>
-              <a:spcAft>
-                <a:spcPts val="1000"/>
-              </a:spcAft>
-            </a:pPr>
-            <a:r>
-              <a:rPr sz="2000" b="0">
-                <a:solidFill>
-                  <a:srgbClr val="1F3A5F"/>
-                </a:solidFill>
-                <a:latin typeface="Microsoft YaHei"/>
-                <a:ea typeface="Microsoft YaHei"/>
-              </a:rPr>
-              <a:t>•  在 2ep 与 8ep 中均被漏检，是持续困难的样本</a:t>
-            </a:r>
-          </a:p>
-          <a:p>
-            <a:pPr>
-              <a:spcAft>
-                <a:spcPts val="1000"/>
-              </a:spcAft>
-            </a:pPr>
-            <a:r>
-              <a:rPr sz="2000" b="1">
-                <a:solidFill>
-                  <a:srgbClr val="1F3A5F"/>
-                </a:solidFill>
-                <a:latin typeface="Microsoft YaHei"/>
-                <a:ea typeface="Microsoft YaHei"/>
-              </a:rPr>
-              <a:t>•  漏检是筛查场景最危险的错误</a:t>
-            </a:r>
-          </a:p>
-        </p:txBody>
-      </p:sp>
-      <p:sp>
-        <p:nvSpPr>
-          <p:cNvPr id="6" name="TextBox 5"/>
-          <p:cNvSpPr txBox="1"/>
-          <p:nvPr/>
-        </p:nvSpPr>
-        <p:spPr>
-          <a:xfrm>
-            <a:off x="11155680" y="6446520"/>
-            <a:ext cx="914400" cy="365760"/>
-          </a:xfrm>
-          <a:prstGeom prst="rect">
-            <a:avLst/>
-          </a:prstGeom>
-          <a:noFill/>
-        </p:spPr>
-        <p:txBody>
-          <a:bodyPr wrap="square">
-            <a:spAutoFit/>
-          </a:bodyPr>
-          <a:lstStyle/>
-          <a:p>
-            <a:pPr algn="r"/>
-            <a:r>
-              <a:rPr sz="1200" b="0">
-                <a:solidFill>
-                  <a:srgbClr val="4A4A4A"/>
-                </a:solidFill>
-                <a:latin typeface="Microsoft YaHei"/>
-                <a:ea typeface="Microsoft YaHei"/>
-              </a:rPr>
-              <a:t>09</a:t>
             </a:r>
           </a:p>
         </p:txBody>

</xml_diff>